<commit_message>
feat: add live Figma canvas URL buttons and update anonymous survey references across web app and deck
</commit_message>
<xml_diff>
--- a/Myntra_Wishlist_Studio_10_Slide_Deck_Updated.pptx
+++ b/Myntra_Wishlist_Studio_10_Slide_Deck_Updated.pptx
@@ -3779,7 +3779,7 @@
               </a:defRPr>
             </a:pPr>
             <a:r>
-              <a:t>Live Deployed MVP: https://myntra-growth-lab.vercel.app | System Architecture &amp; Strategy Plans: 01_ to 08_ specifications</a:t>
+              <a:t>Live Deployed MVP: https://myntra-growth-lab.vercel.app | Live Figma Canvas: https://www.figma.com/design/EtSP7uuOBjzS2b5uA8qaml/Myntra-MVP-NL?node-id=1-2</a:t>
             </a:r>
           </a:p>
         </p:txBody>
@@ -12142,7 +12142,7 @@
               </a:defRPr>
             </a:pPr>
             <a:r>
-              <a:t>★ 🚀 PUBLICLY ACCESSIBLE MVP DEPLOYMENT LINK</a:t>
+              <a:t>★ 🚀 PUBLICLY ACCESSIBLE MVP DEPLOYMENT &amp; FIGMA CANVAS LINKS</a:t>
             </a:r>
           </a:p>
           <a:p>
@@ -12154,7 +12154,7 @@
               </a:defRPr>
             </a:pPr>
             <a:r>
-              <a:t>Interactive Prototype Deployed Live at https://myntra-growth-lab.vercel.app | Built with React 18, Vite, Lucide Icons, and Custom Design System.</a:t>
+              <a:t>Live Prototype: https://myntra-growth-lab.vercel.app | Figma Canvas: https://www.figma.com/design/EtSP7uuOBjzS2b5uA8qaml/Myntra-MVP-NL?node-id=1-2</a:t>
             </a:r>
           </a:p>
         </p:txBody>

</xml_diff>

<commit_message>
Fix deck typography, line spacing, margins, and hanging bullet indentation according to industry standards, and remove unnecessary legacy files
</commit_message>
<xml_diff>
--- a/Myntra_Wishlist_Studio_10_Slide_Deck_Updated.pptx
+++ b/Myntra_Wishlist_Studio_10_Slide_Deck_Updated.pptx
@@ -3133,10 +3133,16 @@
           </a:fontRef>
         </p:style>
         <p:txBody>
-          <a:bodyPr rtlCol="0" anchor="ctr" wrap="square"/>
+          <a:bodyPr rtlCol="0" anchor="ctr" wrap="square" tIns="18288" bIns="18288"/>
           <a:lstStyle/>
           <a:p>
             <a:pPr algn="ctr">
+              <a:spcBef>
+                <a:spcPts val="0"/>
+              </a:spcBef>
+              <a:spcAft>
+                <a:spcPts val="0"/>
+              </a:spcAft>
               <a:defRPr sz="1000" b="1">
                 <a:solidFill>
                   <a:srgbClr val="FFFFFF"/>
@@ -3166,13 +3172,16 @@
           <a:noFill/>
         </p:spPr>
         <p:txBody>
-          <a:bodyPr wrap="square">
+          <a:bodyPr wrap="square" lIns="0" rIns="0" tIns="0" bIns="0">
             <a:spAutoFit/>
           </a:bodyPr>
           <a:lstStyle/>
           <a:p>
             <a:pPr>
-              <a:defRPr sz="1450" b="1">
+              <a:spcAft>
+                <a:spcPts val="300"/>
+              </a:spcAft>
+              <a:defRPr sz="1400" b="1">
                 <a:solidFill>
                   <a:srgbClr val="282C3F"/>
                 </a:solidFill>
@@ -3184,7 +3193,13 @@
           </a:p>
           <a:p>
             <a:pPr>
-              <a:defRPr sz="1150" b="1">
+              <a:spcBef>
+                <a:spcPts val="200"/>
+              </a:spcBef>
+              <a:spcAft>
+                <a:spcPts val="400"/>
+              </a:spcAft>
+              <a:defRPr sz="1050" b="1">
                 <a:solidFill>
                   <a:srgbClr val="FF3F6C"/>
                 </a:solidFill>
@@ -3213,7 +3228,7 @@
           <a:noFill/>
         </p:spPr>
         <p:txBody>
-          <a:bodyPr wrap="none">
+          <a:bodyPr wrap="none" lIns="0" rIns="0" tIns="0" bIns="0">
             <a:spAutoFit/>
           </a:bodyPr>
           <a:lstStyle/>
@@ -3284,8 +3299,8 @@
         </p:nvSpPr>
         <p:spPr>
           <a:xfrm>
-            <a:off x="777240" y="1783080"/>
-            <a:ext cx="3840480" cy="3520440"/>
+            <a:off x="749808" y="1755648"/>
+            <a:ext cx="3895344" cy="3575304"/>
           </a:xfrm>
           <a:prstGeom prst="rect">
             <a:avLst/>
@@ -3293,12 +3308,15 @@
           <a:noFill/>
         </p:spPr>
         <p:txBody>
-          <a:bodyPr wrap="square">
+          <a:bodyPr wrap="square" tIns="73152" bIns="73152">
             <a:spAutoFit/>
           </a:bodyPr>
           <a:lstStyle/>
           <a:p>
             <a:pPr>
+              <a:spcAft>
+                <a:spcPts val="800"/>
+              </a:spcAft>
               <a:defRPr sz="1100" b="1">
                 <a:solidFill>
                   <a:srgbClr val="FF3F6C"/>
@@ -3311,7 +3329,16 @@
           </a:p>
           <a:p>
             <a:pPr>
-              <a:defRPr sz="1000"/>
+              <a:lnSpc>
+                <a:spcPct val="118000"/>
+              </a:lnSpc>
+              <a:spcBef>
+                <a:spcPts val="200"/>
+              </a:spcBef>
+              <a:spcAft>
+                <a:spcPts val="500"/>
+              </a:spcAft>
+              <a:defRPr sz="950"/>
             </a:pPr>
             <a:r>
               <a:rPr b="1">
@@ -3340,7 +3367,16 @@
           </a:p>
           <a:p>
             <a:pPr>
-              <a:defRPr sz="1000"/>
+              <a:lnSpc>
+                <a:spcPct val="118000"/>
+              </a:lnSpc>
+              <a:spcBef>
+                <a:spcPts val="200"/>
+              </a:spcBef>
+              <a:spcAft>
+                <a:spcPts val="500"/>
+              </a:spcAft>
+              <a:defRPr sz="950"/>
             </a:pPr>
             <a:r>
               <a:rPr b="1">
@@ -3369,7 +3405,16 @@
           </a:p>
           <a:p>
             <a:pPr>
-              <a:defRPr sz="1000"/>
+              <a:lnSpc>
+                <a:spcPct val="118000"/>
+              </a:lnSpc>
+              <a:spcBef>
+                <a:spcPts val="200"/>
+              </a:spcBef>
+              <a:spcAft>
+                <a:spcPts val="500"/>
+              </a:spcAft>
+              <a:defRPr sz="950"/>
             </a:pPr>
             <a:r>
               <a:rPr b="1">
@@ -3398,7 +3443,16 @@
           </a:p>
           <a:p>
             <a:pPr>
-              <a:defRPr sz="1000"/>
+              <a:lnSpc>
+                <a:spcPct val="118000"/>
+              </a:lnSpc>
+              <a:spcBef>
+                <a:spcPts val="200"/>
+              </a:spcBef>
+              <a:spcAft>
+                <a:spcPts val="500"/>
+              </a:spcAft>
+              <a:defRPr sz="950"/>
             </a:pPr>
             <a:r>
               <a:rPr b="1">
@@ -3480,8 +3534,8 @@
         </p:nvSpPr>
         <p:spPr>
           <a:xfrm>
-            <a:off x="5029200" y="1783080"/>
-            <a:ext cx="3840480" cy="3520440"/>
+            <a:off x="5001768" y="1755648"/>
+            <a:ext cx="3895344" cy="3575304"/>
           </a:xfrm>
           <a:prstGeom prst="rect">
             <a:avLst/>
@@ -3489,12 +3543,15 @@
           <a:noFill/>
         </p:spPr>
         <p:txBody>
-          <a:bodyPr wrap="square">
+          <a:bodyPr wrap="square" tIns="73152" bIns="73152">
             <a:spAutoFit/>
           </a:bodyPr>
           <a:lstStyle/>
           <a:p>
             <a:pPr>
+              <a:spcAft>
+                <a:spcPts val="800"/>
+              </a:spcAft>
               <a:defRPr sz="1100" b="1">
                 <a:solidFill>
                   <a:srgbClr val="FF3F6C"/>
@@ -3507,7 +3564,16 @@
           </a:p>
           <a:p>
             <a:pPr>
-              <a:defRPr sz="1000"/>
+              <a:lnSpc>
+                <a:spcPct val="118000"/>
+              </a:lnSpc>
+              <a:spcBef>
+                <a:spcPts val="200"/>
+              </a:spcBef>
+              <a:spcAft>
+                <a:spcPts val="500"/>
+              </a:spcAft>
+              <a:defRPr sz="950"/>
             </a:pPr>
             <a:r>
               <a:rPr b="1">
@@ -3536,7 +3602,16 @@
           </a:p>
           <a:p>
             <a:pPr>
-              <a:defRPr sz="1000"/>
+              <a:lnSpc>
+                <a:spcPct val="118000"/>
+              </a:lnSpc>
+              <a:spcBef>
+                <a:spcPts val="200"/>
+              </a:spcBef>
+              <a:spcAft>
+                <a:spcPts val="500"/>
+              </a:spcAft>
+              <a:defRPr sz="950"/>
             </a:pPr>
             <a:r>
               <a:rPr b="1">
@@ -3565,7 +3640,16 @@
           </a:p>
           <a:p>
             <a:pPr>
-              <a:defRPr sz="1000"/>
+              <a:lnSpc>
+                <a:spcPct val="118000"/>
+              </a:lnSpc>
+              <a:spcBef>
+                <a:spcPts val="200"/>
+              </a:spcBef>
+              <a:spcAft>
+                <a:spcPts val="500"/>
+              </a:spcAft>
+              <a:defRPr sz="950"/>
             </a:pPr>
             <a:r>
               <a:rPr b="1">
@@ -3594,7 +3678,16 @@
           </a:p>
           <a:p>
             <a:pPr>
-              <a:defRPr sz="1000"/>
+              <a:lnSpc>
+                <a:spcPct val="118000"/>
+              </a:lnSpc>
+              <a:spcBef>
+                <a:spcPts val="200"/>
+              </a:spcBef>
+              <a:spcAft>
+                <a:spcPts val="500"/>
+              </a:spcAft>
+              <a:defRPr sz="950"/>
             </a:pPr>
             <a:r>
               <a:rPr b="1">
@@ -3745,8 +3838,8 @@
         </p:nvSpPr>
         <p:spPr>
           <a:xfrm>
-            <a:off x="777240" y="5605272"/>
-            <a:ext cx="10637215" cy="493776"/>
+            <a:off x="777240" y="5586984"/>
+            <a:ext cx="10637215" cy="530352"/>
           </a:xfrm>
           <a:prstGeom prst="rect">
             <a:avLst/>
@@ -3754,13 +3847,16 @@
           <a:noFill/>
         </p:spPr>
         <p:txBody>
-          <a:bodyPr wrap="square">
+          <a:bodyPr wrap="square" tIns="36576" bIns="36576">
             <a:spAutoFit/>
           </a:bodyPr>
           <a:lstStyle/>
           <a:p>
             <a:pPr>
-              <a:defRPr sz="1000" b="1">
+              <a:spcAft>
+                <a:spcPts val="200"/>
+              </a:spcAft>
+              <a:defRPr sz="950" b="1">
                 <a:solidFill>
                   <a:srgbClr val="4338CA"/>
                 </a:solidFill>
@@ -3772,7 +3868,13 @@
           </a:p>
           <a:p>
             <a:pPr>
-              <a:defRPr sz="1000" b="1">
+              <a:lnSpc>
+                <a:spcPct val="115000"/>
+              </a:lnSpc>
+              <a:spcBef>
+                <a:spcPts val="0"/>
+              </a:spcBef>
+              <a:defRPr sz="950" b="1">
                 <a:solidFill>
                   <a:srgbClr val="282C3F"/>
                 </a:solidFill>
@@ -3822,10 +3924,16 @@
           </a:fontRef>
         </p:style>
         <p:txBody>
-          <a:bodyPr rtlCol="0" anchor="ctr"/>
+          <a:bodyPr rtlCol="0" anchor="ctr" lIns="18288" rIns="18288" tIns="18288" bIns="18288"/>
           <a:lstStyle/>
           <a:p>
             <a:pPr algn="ctr">
+              <a:spcBef>
+                <a:spcPts val="0"/>
+              </a:spcBef>
+              <a:spcAft>
+                <a:spcPts val="0"/>
+              </a:spcAft>
               <a:defRPr sz="900" b="1">
                 <a:solidFill>
                   <a:srgbClr val="FFFFFF"/>
@@ -3876,10 +3984,16 @@
           </a:fontRef>
         </p:style>
         <p:txBody>
-          <a:bodyPr rtlCol="0" anchor="ctr"/>
+          <a:bodyPr rtlCol="0" anchor="ctr" lIns="18288" rIns="18288" tIns="18288" bIns="18288"/>
           <a:lstStyle/>
           <a:p>
             <a:pPr algn="ctr">
+              <a:spcBef>
+                <a:spcPts val="0"/>
+              </a:spcBef>
+              <a:spcAft>
+                <a:spcPts val="0"/>
+              </a:spcAft>
               <a:defRPr sz="900" b="1">
                 <a:solidFill>
                   <a:srgbClr val="535766"/>
@@ -3930,10 +4044,16 @@
           </a:fontRef>
         </p:style>
         <p:txBody>
-          <a:bodyPr rtlCol="0" anchor="ctr"/>
+          <a:bodyPr rtlCol="0" anchor="ctr" lIns="18288" rIns="18288" tIns="18288" bIns="18288"/>
           <a:lstStyle/>
           <a:p>
             <a:pPr algn="ctr">
+              <a:spcBef>
+                <a:spcPts val="0"/>
+              </a:spcBef>
+              <a:spcAft>
+                <a:spcPts val="0"/>
+              </a:spcAft>
               <a:defRPr sz="900" b="1">
                 <a:solidFill>
                   <a:srgbClr val="535766"/>
@@ -3984,10 +4104,16 @@
           </a:fontRef>
         </p:style>
         <p:txBody>
-          <a:bodyPr rtlCol="0" anchor="ctr"/>
+          <a:bodyPr rtlCol="0" anchor="ctr" lIns="18288" rIns="18288" tIns="18288" bIns="18288"/>
           <a:lstStyle/>
           <a:p>
             <a:pPr algn="ctr">
+              <a:spcBef>
+                <a:spcPts val="0"/>
+              </a:spcBef>
+              <a:spcAft>
+                <a:spcPts val="0"/>
+              </a:spcAft>
               <a:defRPr sz="900" b="1">
                 <a:solidFill>
                   <a:srgbClr val="535766"/>
@@ -4038,10 +4164,16 @@
           </a:fontRef>
         </p:style>
         <p:txBody>
-          <a:bodyPr rtlCol="0" anchor="ctr"/>
+          <a:bodyPr rtlCol="0" anchor="ctr" lIns="18288" rIns="18288" tIns="18288" bIns="18288"/>
           <a:lstStyle/>
           <a:p>
             <a:pPr algn="ctr">
+              <a:spcBef>
+                <a:spcPts val="0"/>
+              </a:spcBef>
+              <a:spcAft>
+                <a:spcPts val="0"/>
+              </a:spcAft>
               <a:defRPr sz="900" b="1">
                 <a:solidFill>
                   <a:srgbClr val="535766"/>
@@ -4092,10 +4224,16 @@
           </a:fontRef>
         </p:style>
         <p:txBody>
-          <a:bodyPr rtlCol="0" anchor="ctr"/>
+          <a:bodyPr rtlCol="0" anchor="ctr" lIns="18288" rIns="18288" tIns="18288" bIns="18288"/>
           <a:lstStyle/>
           <a:p>
             <a:pPr algn="ctr">
+              <a:spcBef>
+                <a:spcPts val="0"/>
+              </a:spcBef>
+              <a:spcAft>
+                <a:spcPts val="0"/>
+              </a:spcAft>
               <a:defRPr sz="900" b="1">
                 <a:solidFill>
                   <a:srgbClr val="535766"/>
@@ -4146,10 +4284,16 @@
           </a:fontRef>
         </p:style>
         <p:txBody>
-          <a:bodyPr rtlCol="0" anchor="ctr"/>
+          <a:bodyPr rtlCol="0" anchor="ctr" lIns="18288" rIns="18288" tIns="18288" bIns="18288"/>
           <a:lstStyle/>
           <a:p>
             <a:pPr algn="ctr">
+              <a:spcBef>
+                <a:spcPts val="0"/>
+              </a:spcBef>
+              <a:spcAft>
+                <a:spcPts val="0"/>
+              </a:spcAft>
               <a:defRPr sz="900" b="1">
                 <a:solidFill>
                   <a:srgbClr val="535766"/>
@@ -4200,10 +4344,16 @@
           </a:fontRef>
         </p:style>
         <p:txBody>
-          <a:bodyPr rtlCol="0" anchor="ctr"/>
+          <a:bodyPr rtlCol="0" anchor="ctr" lIns="18288" rIns="18288" tIns="18288" bIns="18288"/>
           <a:lstStyle/>
           <a:p>
             <a:pPr algn="ctr">
+              <a:spcBef>
+                <a:spcPts val="0"/>
+              </a:spcBef>
+              <a:spcAft>
+                <a:spcPts val="0"/>
+              </a:spcAft>
               <a:defRPr sz="900" b="1">
                 <a:solidFill>
                   <a:srgbClr val="535766"/>
@@ -4254,10 +4404,16 @@
           </a:fontRef>
         </p:style>
         <p:txBody>
-          <a:bodyPr rtlCol="0" anchor="ctr"/>
+          <a:bodyPr rtlCol="0" anchor="ctr" lIns="18288" rIns="18288" tIns="18288" bIns="18288"/>
           <a:lstStyle/>
           <a:p>
             <a:pPr algn="ctr">
+              <a:spcBef>
+                <a:spcPts val="0"/>
+              </a:spcBef>
+              <a:spcAft>
+                <a:spcPts val="0"/>
+              </a:spcAft>
               <a:defRPr sz="900" b="1">
                 <a:solidFill>
                   <a:srgbClr val="535766"/>
@@ -4308,10 +4464,16 @@
           </a:fontRef>
         </p:style>
         <p:txBody>
-          <a:bodyPr rtlCol="0" anchor="ctr"/>
+          <a:bodyPr rtlCol="0" anchor="ctr" lIns="18288" rIns="18288" tIns="18288" bIns="18288"/>
           <a:lstStyle/>
           <a:p>
             <a:pPr algn="ctr">
+              <a:spcBef>
+                <a:spcPts val="0"/>
+              </a:spcBef>
+              <a:spcAft>
+                <a:spcPts val="0"/>
+              </a:spcAft>
               <a:defRPr sz="900" b="1">
                 <a:solidFill>
                   <a:srgbClr val="535766"/>
@@ -4378,10 +4540,16 @@
           </a:fontRef>
         </p:style>
         <p:txBody>
-          <a:bodyPr rtlCol="0" anchor="ctr" wrap="square"/>
+          <a:bodyPr rtlCol="0" anchor="ctr" wrap="square" tIns="18288" bIns="18288"/>
           <a:lstStyle/>
           <a:p>
             <a:pPr algn="ctr">
+              <a:spcBef>
+                <a:spcPts val="0"/>
+              </a:spcBef>
+              <a:spcAft>
+                <a:spcPts val="0"/>
+              </a:spcAft>
               <a:defRPr sz="1000" b="1">
                 <a:solidFill>
                   <a:srgbClr val="FFFFFF"/>
@@ -4411,13 +4579,16 @@
           <a:noFill/>
         </p:spPr>
         <p:txBody>
-          <a:bodyPr wrap="square">
+          <a:bodyPr wrap="square" lIns="0" rIns="0" tIns="0" bIns="0">
             <a:spAutoFit/>
           </a:bodyPr>
           <a:lstStyle/>
           <a:p>
             <a:pPr>
-              <a:defRPr sz="1450" b="1">
+              <a:spcAft>
+                <a:spcPts val="300"/>
+              </a:spcAft>
+              <a:defRPr sz="1400" b="1">
                 <a:solidFill>
                   <a:srgbClr val="282C3F"/>
                 </a:solidFill>
@@ -4429,7 +4600,13 @@
           </a:p>
           <a:p>
             <a:pPr>
-              <a:defRPr sz="1150" b="1">
+              <a:spcBef>
+                <a:spcPts val="200"/>
+              </a:spcBef>
+              <a:spcAft>
+                <a:spcPts val="400"/>
+              </a:spcAft>
+              <a:defRPr sz="1050" b="1">
                 <a:solidFill>
                   <a:srgbClr val="FF3F6C"/>
                 </a:solidFill>
@@ -4458,7 +4635,7 @@
           <a:noFill/>
         </p:spPr>
         <p:txBody>
-          <a:bodyPr wrap="none">
+          <a:bodyPr wrap="none" lIns="0" rIns="0" tIns="0" bIns="0">
             <a:spAutoFit/>
           </a:bodyPr>
           <a:lstStyle/>
@@ -4529,8 +4706,8 @@
         </p:nvSpPr>
         <p:spPr>
           <a:xfrm>
-            <a:off x="777240" y="1783080"/>
-            <a:ext cx="3840480" cy="3520440"/>
+            <a:off x="749808" y="1755648"/>
+            <a:ext cx="3895344" cy="3575304"/>
           </a:xfrm>
           <a:prstGeom prst="rect">
             <a:avLst/>
@@ -4538,12 +4715,15 @@
           <a:noFill/>
         </p:spPr>
         <p:txBody>
-          <a:bodyPr wrap="square">
+          <a:bodyPr wrap="square" tIns="73152" bIns="73152">
             <a:spAutoFit/>
           </a:bodyPr>
           <a:lstStyle/>
           <a:p>
             <a:pPr>
+              <a:spcAft>
+                <a:spcPts val="800"/>
+              </a:spcAft>
               <a:defRPr sz="1100" b="1">
                 <a:solidFill>
                   <a:srgbClr val="FF3F6C"/>
@@ -4556,7 +4736,16 @@
           </a:p>
           <a:p>
             <a:pPr>
-              <a:defRPr sz="1000"/>
+              <a:lnSpc>
+                <a:spcPct val="118000"/>
+              </a:lnSpc>
+              <a:spcBef>
+                <a:spcPts val="200"/>
+              </a:spcBef>
+              <a:spcAft>
+                <a:spcPts val="500"/>
+              </a:spcAft>
+              <a:defRPr sz="950"/>
             </a:pPr>
             <a:r>
               <a:rPr b="1">
@@ -4585,7 +4774,16 @@
           </a:p>
           <a:p>
             <a:pPr>
-              <a:defRPr sz="1000"/>
+              <a:lnSpc>
+                <a:spcPct val="118000"/>
+              </a:lnSpc>
+              <a:spcBef>
+                <a:spcPts val="200"/>
+              </a:spcBef>
+              <a:spcAft>
+                <a:spcPts val="500"/>
+              </a:spcAft>
+              <a:defRPr sz="950"/>
             </a:pPr>
             <a:r>
               <a:rPr b="1">
@@ -4614,7 +4812,16 @@
           </a:p>
           <a:p>
             <a:pPr>
-              <a:defRPr sz="1000"/>
+              <a:lnSpc>
+                <a:spcPct val="118000"/>
+              </a:lnSpc>
+              <a:spcBef>
+                <a:spcPts val="200"/>
+              </a:spcBef>
+              <a:spcAft>
+                <a:spcPts val="500"/>
+              </a:spcAft>
+              <a:defRPr sz="950"/>
             </a:pPr>
             <a:r>
               <a:rPr b="1">
@@ -4643,7 +4850,16 @@
           </a:p>
           <a:p>
             <a:pPr>
-              <a:defRPr sz="1000"/>
+              <a:lnSpc>
+                <a:spcPct val="118000"/>
+              </a:lnSpc>
+              <a:spcBef>
+                <a:spcPts val="200"/>
+              </a:spcBef>
+              <a:spcAft>
+                <a:spcPts val="500"/>
+              </a:spcAft>
+              <a:defRPr sz="950"/>
             </a:pPr>
             <a:r>
               <a:rPr b="1">
@@ -4725,8 +4941,8 @@
         </p:nvSpPr>
         <p:spPr>
           <a:xfrm>
-            <a:off x="5029200" y="1783080"/>
-            <a:ext cx="3840480" cy="3520440"/>
+            <a:off x="5001768" y="1755648"/>
+            <a:ext cx="3895344" cy="3575304"/>
           </a:xfrm>
           <a:prstGeom prst="rect">
             <a:avLst/>
@@ -4734,12 +4950,15 @@
           <a:noFill/>
         </p:spPr>
         <p:txBody>
-          <a:bodyPr wrap="square">
+          <a:bodyPr wrap="square" tIns="73152" bIns="73152">
             <a:spAutoFit/>
           </a:bodyPr>
           <a:lstStyle/>
           <a:p>
             <a:pPr>
+              <a:spcAft>
+                <a:spcPts val="800"/>
+              </a:spcAft>
               <a:defRPr sz="1100" b="1">
                 <a:solidFill>
                   <a:srgbClr val="FF3F6C"/>
@@ -4752,7 +4971,16 @@
           </a:p>
           <a:p>
             <a:pPr>
-              <a:defRPr sz="1000"/>
+              <a:lnSpc>
+                <a:spcPct val="118000"/>
+              </a:lnSpc>
+              <a:spcBef>
+                <a:spcPts val="200"/>
+              </a:spcBef>
+              <a:spcAft>
+                <a:spcPts val="500"/>
+              </a:spcAft>
+              <a:defRPr sz="950"/>
             </a:pPr>
             <a:r>
               <a:rPr b="1">
@@ -4781,7 +5009,16 @@
           </a:p>
           <a:p>
             <a:pPr>
-              <a:defRPr sz="1000"/>
+              <a:lnSpc>
+                <a:spcPct val="118000"/>
+              </a:lnSpc>
+              <a:spcBef>
+                <a:spcPts val="200"/>
+              </a:spcBef>
+              <a:spcAft>
+                <a:spcPts val="500"/>
+              </a:spcAft>
+              <a:defRPr sz="950"/>
             </a:pPr>
             <a:r>
               <a:rPr b="1">
@@ -4810,7 +5047,16 @@
           </a:p>
           <a:p>
             <a:pPr>
-              <a:defRPr sz="1000"/>
+              <a:lnSpc>
+                <a:spcPct val="118000"/>
+              </a:lnSpc>
+              <a:spcBef>
+                <a:spcPts val="200"/>
+              </a:spcBef>
+              <a:spcAft>
+                <a:spcPts val="500"/>
+              </a:spcAft>
+              <a:defRPr sz="950"/>
             </a:pPr>
             <a:r>
               <a:rPr b="1">
@@ -4839,7 +5085,16 @@
           </a:p>
           <a:p>
             <a:pPr>
-              <a:defRPr sz="1000"/>
+              <a:lnSpc>
+                <a:spcPct val="118000"/>
+              </a:lnSpc>
+              <a:spcBef>
+                <a:spcPts val="200"/>
+              </a:spcBef>
+              <a:spcAft>
+                <a:spcPts val="500"/>
+              </a:spcAft>
+              <a:defRPr sz="950"/>
             </a:pPr>
             <a:r>
               <a:rPr b="1">
@@ -4990,8 +5245,8 @@
         </p:nvSpPr>
         <p:spPr>
           <a:xfrm>
-            <a:off x="777240" y="5605272"/>
-            <a:ext cx="10637215" cy="493776"/>
+            <a:off x="777240" y="5586984"/>
+            <a:ext cx="10637215" cy="530352"/>
           </a:xfrm>
           <a:prstGeom prst="rect">
             <a:avLst/>
@@ -4999,13 +5254,16 @@
           <a:noFill/>
         </p:spPr>
         <p:txBody>
-          <a:bodyPr wrap="square">
+          <a:bodyPr wrap="square" tIns="36576" bIns="36576">
             <a:spAutoFit/>
           </a:bodyPr>
           <a:lstStyle/>
           <a:p>
             <a:pPr>
-              <a:defRPr sz="1000" b="1">
+              <a:spcAft>
+                <a:spcPts val="200"/>
+              </a:spcAft>
+              <a:defRPr sz="950" b="1">
                 <a:solidFill>
                   <a:srgbClr val="4338CA"/>
                 </a:solidFill>
@@ -5017,7 +5275,13 @@
           </a:p>
           <a:p>
             <a:pPr>
-              <a:defRPr sz="1000" b="1">
+              <a:lnSpc>
+                <a:spcPct val="115000"/>
+              </a:lnSpc>
+              <a:spcBef>
+                <a:spcPts val="0"/>
+              </a:spcBef>
+              <a:defRPr sz="950" b="1">
                 <a:solidFill>
                   <a:srgbClr val="282C3F"/>
                 </a:solidFill>
@@ -5067,10 +5331,16 @@
           </a:fontRef>
         </p:style>
         <p:txBody>
-          <a:bodyPr rtlCol="0" anchor="ctr"/>
+          <a:bodyPr rtlCol="0" anchor="ctr" lIns="18288" rIns="18288" tIns="18288" bIns="18288"/>
           <a:lstStyle/>
           <a:p>
             <a:pPr algn="ctr">
+              <a:spcBef>
+                <a:spcPts val="0"/>
+              </a:spcBef>
+              <a:spcAft>
+                <a:spcPts val="0"/>
+              </a:spcAft>
               <a:defRPr sz="900" b="1">
                 <a:solidFill>
                   <a:srgbClr val="535766"/>
@@ -5121,10 +5391,16 @@
           </a:fontRef>
         </p:style>
         <p:txBody>
-          <a:bodyPr rtlCol="0" anchor="ctr"/>
+          <a:bodyPr rtlCol="0" anchor="ctr" lIns="18288" rIns="18288" tIns="18288" bIns="18288"/>
           <a:lstStyle/>
           <a:p>
             <a:pPr algn="ctr">
+              <a:spcBef>
+                <a:spcPts val="0"/>
+              </a:spcBef>
+              <a:spcAft>
+                <a:spcPts val="0"/>
+              </a:spcAft>
               <a:defRPr sz="900" b="1">
                 <a:solidFill>
                   <a:srgbClr val="535766"/>
@@ -5175,10 +5451,16 @@
           </a:fontRef>
         </p:style>
         <p:txBody>
-          <a:bodyPr rtlCol="0" anchor="ctr"/>
+          <a:bodyPr rtlCol="0" anchor="ctr" lIns="18288" rIns="18288" tIns="18288" bIns="18288"/>
           <a:lstStyle/>
           <a:p>
             <a:pPr algn="ctr">
+              <a:spcBef>
+                <a:spcPts val="0"/>
+              </a:spcBef>
+              <a:spcAft>
+                <a:spcPts val="0"/>
+              </a:spcAft>
               <a:defRPr sz="900" b="1">
                 <a:solidFill>
                   <a:srgbClr val="535766"/>
@@ -5229,10 +5511,16 @@
           </a:fontRef>
         </p:style>
         <p:txBody>
-          <a:bodyPr rtlCol="0" anchor="ctr"/>
+          <a:bodyPr rtlCol="0" anchor="ctr" lIns="18288" rIns="18288" tIns="18288" bIns="18288"/>
           <a:lstStyle/>
           <a:p>
             <a:pPr algn="ctr">
+              <a:spcBef>
+                <a:spcPts val="0"/>
+              </a:spcBef>
+              <a:spcAft>
+                <a:spcPts val="0"/>
+              </a:spcAft>
               <a:defRPr sz="900" b="1">
                 <a:solidFill>
                   <a:srgbClr val="535766"/>
@@ -5283,10 +5571,16 @@
           </a:fontRef>
         </p:style>
         <p:txBody>
-          <a:bodyPr rtlCol="0" anchor="ctr"/>
+          <a:bodyPr rtlCol="0" anchor="ctr" lIns="18288" rIns="18288" tIns="18288" bIns="18288"/>
           <a:lstStyle/>
           <a:p>
             <a:pPr algn="ctr">
+              <a:spcBef>
+                <a:spcPts val="0"/>
+              </a:spcBef>
+              <a:spcAft>
+                <a:spcPts val="0"/>
+              </a:spcAft>
               <a:defRPr sz="900" b="1">
                 <a:solidFill>
                   <a:srgbClr val="535766"/>
@@ -5337,10 +5631,16 @@
           </a:fontRef>
         </p:style>
         <p:txBody>
-          <a:bodyPr rtlCol="0" anchor="ctr"/>
+          <a:bodyPr rtlCol="0" anchor="ctr" lIns="18288" rIns="18288" tIns="18288" bIns="18288"/>
           <a:lstStyle/>
           <a:p>
             <a:pPr algn="ctr">
+              <a:spcBef>
+                <a:spcPts val="0"/>
+              </a:spcBef>
+              <a:spcAft>
+                <a:spcPts val="0"/>
+              </a:spcAft>
               <a:defRPr sz="900" b="1">
                 <a:solidFill>
                   <a:srgbClr val="535766"/>
@@ -5391,10 +5691,16 @@
           </a:fontRef>
         </p:style>
         <p:txBody>
-          <a:bodyPr rtlCol="0" anchor="ctr"/>
+          <a:bodyPr rtlCol="0" anchor="ctr" lIns="18288" rIns="18288" tIns="18288" bIns="18288"/>
           <a:lstStyle/>
           <a:p>
             <a:pPr algn="ctr">
+              <a:spcBef>
+                <a:spcPts val="0"/>
+              </a:spcBef>
+              <a:spcAft>
+                <a:spcPts val="0"/>
+              </a:spcAft>
               <a:defRPr sz="900" b="1">
                 <a:solidFill>
                   <a:srgbClr val="535766"/>
@@ -5445,10 +5751,16 @@
           </a:fontRef>
         </p:style>
         <p:txBody>
-          <a:bodyPr rtlCol="0" anchor="ctr"/>
+          <a:bodyPr rtlCol="0" anchor="ctr" lIns="18288" rIns="18288" tIns="18288" bIns="18288"/>
           <a:lstStyle/>
           <a:p>
             <a:pPr algn="ctr">
+              <a:spcBef>
+                <a:spcPts val="0"/>
+              </a:spcBef>
+              <a:spcAft>
+                <a:spcPts val="0"/>
+              </a:spcAft>
               <a:defRPr sz="900" b="1">
                 <a:solidFill>
                   <a:srgbClr val="535766"/>
@@ -5499,10 +5811,16 @@
           </a:fontRef>
         </p:style>
         <p:txBody>
-          <a:bodyPr rtlCol="0" anchor="ctr"/>
+          <a:bodyPr rtlCol="0" anchor="ctr" lIns="18288" rIns="18288" tIns="18288" bIns="18288"/>
           <a:lstStyle/>
           <a:p>
             <a:pPr algn="ctr">
+              <a:spcBef>
+                <a:spcPts val="0"/>
+              </a:spcBef>
+              <a:spcAft>
+                <a:spcPts val="0"/>
+              </a:spcAft>
               <a:defRPr sz="900" b="1">
                 <a:solidFill>
                   <a:srgbClr val="535766"/>
@@ -5553,10 +5871,16 @@
           </a:fontRef>
         </p:style>
         <p:txBody>
-          <a:bodyPr rtlCol="0" anchor="ctr"/>
+          <a:bodyPr rtlCol="0" anchor="ctr" lIns="18288" rIns="18288" tIns="18288" bIns="18288"/>
           <a:lstStyle/>
           <a:p>
             <a:pPr algn="ctr">
+              <a:spcBef>
+                <a:spcPts val="0"/>
+              </a:spcBef>
+              <a:spcAft>
+                <a:spcPts val="0"/>
+              </a:spcAft>
               <a:defRPr sz="900" b="1">
                 <a:solidFill>
                   <a:srgbClr val="FFFFFF"/>
@@ -5623,10 +5947,16 @@
           </a:fontRef>
         </p:style>
         <p:txBody>
-          <a:bodyPr rtlCol="0" anchor="ctr" wrap="square"/>
+          <a:bodyPr rtlCol="0" anchor="ctr" wrap="square" tIns="18288" bIns="18288"/>
           <a:lstStyle/>
           <a:p>
             <a:pPr algn="ctr">
+              <a:spcBef>
+                <a:spcPts val="0"/>
+              </a:spcBef>
+              <a:spcAft>
+                <a:spcPts val="0"/>
+              </a:spcAft>
               <a:defRPr sz="1000" b="1">
                 <a:solidFill>
                   <a:srgbClr val="FFFFFF"/>
@@ -5656,13 +5986,16 @@
           <a:noFill/>
         </p:spPr>
         <p:txBody>
-          <a:bodyPr wrap="square">
+          <a:bodyPr wrap="square" lIns="0" rIns="0" tIns="0" bIns="0">
             <a:spAutoFit/>
           </a:bodyPr>
           <a:lstStyle/>
           <a:p>
             <a:pPr>
-              <a:defRPr sz="1450" b="1">
+              <a:spcAft>
+                <a:spcPts val="300"/>
+              </a:spcAft>
+              <a:defRPr sz="1400" b="1">
                 <a:solidFill>
                   <a:srgbClr val="282C3F"/>
                 </a:solidFill>
@@ -5674,7 +6007,13 @@
           </a:p>
           <a:p>
             <a:pPr>
-              <a:defRPr sz="1150" b="1">
+              <a:spcBef>
+                <a:spcPts val="200"/>
+              </a:spcBef>
+              <a:spcAft>
+                <a:spcPts val="400"/>
+              </a:spcAft>
+              <a:defRPr sz="1050" b="1">
                 <a:solidFill>
                   <a:srgbClr val="FF3F6C"/>
                 </a:solidFill>
@@ -5703,7 +6042,7 @@
           <a:noFill/>
         </p:spPr>
         <p:txBody>
-          <a:bodyPr wrap="none">
+          <a:bodyPr wrap="none" lIns="0" rIns="0" tIns="0" bIns="0">
             <a:spAutoFit/>
           </a:bodyPr>
           <a:lstStyle/>
@@ -5774,8 +6113,8 @@
         </p:nvSpPr>
         <p:spPr>
           <a:xfrm>
-            <a:off x="777240" y="1783080"/>
-            <a:ext cx="3840480" cy="3520440"/>
+            <a:off x="749808" y="1755648"/>
+            <a:ext cx="3895344" cy="3575304"/>
           </a:xfrm>
           <a:prstGeom prst="rect">
             <a:avLst/>
@@ -5783,12 +6122,15 @@
           <a:noFill/>
         </p:spPr>
         <p:txBody>
-          <a:bodyPr wrap="square">
+          <a:bodyPr wrap="square" tIns="73152" bIns="73152">
             <a:spAutoFit/>
           </a:bodyPr>
           <a:lstStyle/>
           <a:p>
             <a:pPr>
+              <a:spcAft>
+                <a:spcPts val="800"/>
+              </a:spcAft>
               <a:defRPr sz="1100" b="1">
                 <a:solidFill>
                   <a:srgbClr val="FF3F6C"/>
@@ -5801,7 +6143,16 @@
           </a:p>
           <a:p>
             <a:pPr>
-              <a:defRPr sz="1000"/>
+              <a:lnSpc>
+                <a:spcPct val="118000"/>
+              </a:lnSpc>
+              <a:spcBef>
+                <a:spcPts val="200"/>
+              </a:spcBef>
+              <a:spcAft>
+                <a:spcPts val="500"/>
+              </a:spcAft>
+              <a:defRPr sz="950"/>
             </a:pPr>
             <a:r>
               <a:rPr b="1">
@@ -5830,7 +6181,16 @@
           </a:p>
           <a:p>
             <a:pPr>
-              <a:defRPr sz="1000"/>
+              <a:lnSpc>
+                <a:spcPct val="118000"/>
+              </a:lnSpc>
+              <a:spcBef>
+                <a:spcPts val="200"/>
+              </a:spcBef>
+              <a:spcAft>
+                <a:spcPts val="500"/>
+              </a:spcAft>
+              <a:defRPr sz="950"/>
             </a:pPr>
             <a:r>
               <a:rPr b="1">
@@ -5859,7 +6219,16 @@
           </a:p>
           <a:p>
             <a:pPr>
-              <a:defRPr sz="1000"/>
+              <a:lnSpc>
+                <a:spcPct val="118000"/>
+              </a:lnSpc>
+              <a:spcBef>
+                <a:spcPts val="200"/>
+              </a:spcBef>
+              <a:spcAft>
+                <a:spcPts val="500"/>
+              </a:spcAft>
+              <a:defRPr sz="950"/>
             </a:pPr>
             <a:r>
               <a:rPr b="1">
@@ -5941,8 +6310,8 @@
         </p:nvSpPr>
         <p:spPr>
           <a:xfrm>
-            <a:off x="5029200" y="1783080"/>
-            <a:ext cx="3840480" cy="3520440"/>
+            <a:off x="5001768" y="1755648"/>
+            <a:ext cx="3895344" cy="3575304"/>
           </a:xfrm>
           <a:prstGeom prst="rect">
             <a:avLst/>
@@ -5950,12 +6319,15 @@
           <a:noFill/>
         </p:spPr>
         <p:txBody>
-          <a:bodyPr wrap="square">
+          <a:bodyPr wrap="square" tIns="73152" bIns="73152">
             <a:spAutoFit/>
           </a:bodyPr>
           <a:lstStyle/>
           <a:p>
             <a:pPr>
+              <a:spcAft>
+                <a:spcPts val="800"/>
+              </a:spcAft>
               <a:defRPr sz="1100" b="1">
                 <a:solidFill>
                   <a:srgbClr val="FF3F6C"/>
@@ -5968,7 +6340,16 @@
           </a:p>
           <a:p>
             <a:pPr>
-              <a:defRPr sz="1000"/>
+              <a:lnSpc>
+                <a:spcPct val="118000"/>
+              </a:lnSpc>
+              <a:spcBef>
+                <a:spcPts val="200"/>
+              </a:spcBef>
+              <a:spcAft>
+                <a:spcPts val="500"/>
+              </a:spcAft>
+              <a:defRPr sz="950"/>
             </a:pPr>
             <a:r>
               <a:rPr b="1">
@@ -5997,7 +6378,16 @@
           </a:p>
           <a:p>
             <a:pPr>
-              <a:defRPr sz="1000"/>
+              <a:lnSpc>
+                <a:spcPct val="118000"/>
+              </a:lnSpc>
+              <a:spcBef>
+                <a:spcPts val="200"/>
+              </a:spcBef>
+              <a:spcAft>
+                <a:spcPts val="500"/>
+              </a:spcAft>
+              <a:defRPr sz="950"/>
             </a:pPr>
             <a:r>
               <a:rPr b="1">
@@ -6026,7 +6416,16 @@
           </a:p>
           <a:p>
             <a:pPr>
-              <a:defRPr sz="1000"/>
+              <a:lnSpc>
+                <a:spcPct val="118000"/>
+              </a:lnSpc>
+              <a:spcBef>
+                <a:spcPts val="200"/>
+              </a:spcBef>
+              <a:spcAft>
+                <a:spcPts val="500"/>
+              </a:spcAft>
+              <a:defRPr sz="950"/>
             </a:pPr>
             <a:r>
               <a:rPr b="1">
@@ -6055,7 +6454,16 @@
           </a:p>
           <a:p>
             <a:pPr>
-              <a:defRPr sz="1000"/>
+              <a:lnSpc>
+                <a:spcPct val="118000"/>
+              </a:lnSpc>
+              <a:spcBef>
+                <a:spcPts val="200"/>
+              </a:spcBef>
+              <a:spcAft>
+                <a:spcPts val="500"/>
+              </a:spcAft>
+              <a:defRPr sz="950"/>
             </a:pPr>
             <a:r>
               <a:rPr b="1">
@@ -6206,8 +6614,8 @@
         </p:nvSpPr>
         <p:spPr>
           <a:xfrm>
-            <a:off x="777240" y="5605272"/>
-            <a:ext cx="10637215" cy="493776"/>
+            <a:off x="777240" y="5586984"/>
+            <a:ext cx="10637215" cy="530352"/>
           </a:xfrm>
           <a:prstGeom prst="rect">
             <a:avLst/>
@@ -6215,13 +6623,16 @@
           <a:noFill/>
         </p:spPr>
         <p:txBody>
-          <a:bodyPr wrap="square">
+          <a:bodyPr wrap="square" tIns="36576" bIns="36576">
             <a:spAutoFit/>
           </a:bodyPr>
           <a:lstStyle/>
           <a:p>
             <a:pPr>
-              <a:defRPr sz="1000" b="1">
+              <a:spcAft>
+                <a:spcPts val="200"/>
+              </a:spcAft>
+              <a:defRPr sz="950" b="1">
                 <a:solidFill>
                   <a:srgbClr val="4338CA"/>
                 </a:solidFill>
@@ -6233,7 +6644,13 @@
           </a:p>
           <a:p>
             <a:pPr>
-              <a:defRPr sz="1000" b="1">
+              <a:lnSpc>
+                <a:spcPct val="115000"/>
+              </a:lnSpc>
+              <a:spcBef>
+                <a:spcPts val="0"/>
+              </a:spcBef>
+              <a:defRPr sz="950" b="1">
                 <a:solidFill>
                   <a:srgbClr val="282C3F"/>
                 </a:solidFill>
@@ -6283,10 +6700,16 @@
           </a:fontRef>
         </p:style>
         <p:txBody>
-          <a:bodyPr rtlCol="0" anchor="ctr"/>
+          <a:bodyPr rtlCol="0" anchor="ctr" lIns="18288" rIns="18288" tIns="18288" bIns="18288"/>
           <a:lstStyle/>
           <a:p>
             <a:pPr algn="ctr">
+              <a:spcBef>
+                <a:spcPts val="0"/>
+              </a:spcBef>
+              <a:spcAft>
+                <a:spcPts val="0"/>
+              </a:spcAft>
               <a:defRPr sz="900" b="1">
                 <a:solidFill>
                   <a:srgbClr val="535766"/>
@@ -6337,10 +6760,16 @@
           </a:fontRef>
         </p:style>
         <p:txBody>
-          <a:bodyPr rtlCol="0" anchor="ctr"/>
+          <a:bodyPr rtlCol="0" anchor="ctr" lIns="18288" rIns="18288" tIns="18288" bIns="18288"/>
           <a:lstStyle/>
           <a:p>
             <a:pPr algn="ctr">
+              <a:spcBef>
+                <a:spcPts val="0"/>
+              </a:spcBef>
+              <a:spcAft>
+                <a:spcPts val="0"/>
+              </a:spcAft>
               <a:defRPr sz="900" b="1">
                 <a:solidFill>
                   <a:srgbClr val="FFFFFF"/>
@@ -6391,10 +6820,16 @@
           </a:fontRef>
         </p:style>
         <p:txBody>
-          <a:bodyPr rtlCol="0" anchor="ctr"/>
+          <a:bodyPr rtlCol="0" anchor="ctr" lIns="18288" rIns="18288" tIns="18288" bIns="18288"/>
           <a:lstStyle/>
           <a:p>
             <a:pPr algn="ctr">
+              <a:spcBef>
+                <a:spcPts val="0"/>
+              </a:spcBef>
+              <a:spcAft>
+                <a:spcPts val="0"/>
+              </a:spcAft>
               <a:defRPr sz="900" b="1">
                 <a:solidFill>
                   <a:srgbClr val="535766"/>
@@ -6445,10 +6880,16 @@
           </a:fontRef>
         </p:style>
         <p:txBody>
-          <a:bodyPr rtlCol="0" anchor="ctr"/>
+          <a:bodyPr rtlCol="0" anchor="ctr" lIns="18288" rIns="18288" tIns="18288" bIns="18288"/>
           <a:lstStyle/>
           <a:p>
             <a:pPr algn="ctr">
+              <a:spcBef>
+                <a:spcPts val="0"/>
+              </a:spcBef>
+              <a:spcAft>
+                <a:spcPts val="0"/>
+              </a:spcAft>
               <a:defRPr sz="900" b="1">
                 <a:solidFill>
                   <a:srgbClr val="535766"/>
@@ -6499,10 +6940,16 @@
           </a:fontRef>
         </p:style>
         <p:txBody>
-          <a:bodyPr rtlCol="0" anchor="ctr"/>
+          <a:bodyPr rtlCol="0" anchor="ctr" lIns="18288" rIns="18288" tIns="18288" bIns="18288"/>
           <a:lstStyle/>
           <a:p>
             <a:pPr algn="ctr">
+              <a:spcBef>
+                <a:spcPts val="0"/>
+              </a:spcBef>
+              <a:spcAft>
+                <a:spcPts val="0"/>
+              </a:spcAft>
               <a:defRPr sz="900" b="1">
                 <a:solidFill>
                   <a:srgbClr val="535766"/>
@@ -6553,10 +7000,16 @@
           </a:fontRef>
         </p:style>
         <p:txBody>
-          <a:bodyPr rtlCol="0" anchor="ctr"/>
+          <a:bodyPr rtlCol="0" anchor="ctr" lIns="18288" rIns="18288" tIns="18288" bIns="18288"/>
           <a:lstStyle/>
           <a:p>
             <a:pPr algn="ctr">
+              <a:spcBef>
+                <a:spcPts val="0"/>
+              </a:spcBef>
+              <a:spcAft>
+                <a:spcPts val="0"/>
+              </a:spcAft>
               <a:defRPr sz="900" b="1">
                 <a:solidFill>
                   <a:srgbClr val="535766"/>
@@ -6607,10 +7060,16 @@
           </a:fontRef>
         </p:style>
         <p:txBody>
-          <a:bodyPr rtlCol="0" anchor="ctr"/>
+          <a:bodyPr rtlCol="0" anchor="ctr" lIns="18288" rIns="18288" tIns="18288" bIns="18288"/>
           <a:lstStyle/>
           <a:p>
             <a:pPr algn="ctr">
+              <a:spcBef>
+                <a:spcPts val="0"/>
+              </a:spcBef>
+              <a:spcAft>
+                <a:spcPts val="0"/>
+              </a:spcAft>
               <a:defRPr sz="900" b="1">
                 <a:solidFill>
                   <a:srgbClr val="535766"/>
@@ -6661,10 +7120,16 @@
           </a:fontRef>
         </p:style>
         <p:txBody>
-          <a:bodyPr rtlCol="0" anchor="ctr"/>
+          <a:bodyPr rtlCol="0" anchor="ctr" lIns="18288" rIns="18288" tIns="18288" bIns="18288"/>
           <a:lstStyle/>
           <a:p>
             <a:pPr algn="ctr">
+              <a:spcBef>
+                <a:spcPts val="0"/>
+              </a:spcBef>
+              <a:spcAft>
+                <a:spcPts val="0"/>
+              </a:spcAft>
               <a:defRPr sz="900" b="1">
                 <a:solidFill>
                   <a:srgbClr val="535766"/>
@@ -6715,10 +7180,16 @@
           </a:fontRef>
         </p:style>
         <p:txBody>
-          <a:bodyPr rtlCol="0" anchor="ctr"/>
+          <a:bodyPr rtlCol="0" anchor="ctr" lIns="18288" rIns="18288" tIns="18288" bIns="18288"/>
           <a:lstStyle/>
           <a:p>
             <a:pPr algn="ctr">
+              <a:spcBef>
+                <a:spcPts val="0"/>
+              </a:spcBef>
+              <a:spcAft>
+                <a:spcPts val="0"/>
+              </a:spcAft>
               <a:defRPr sz="900" b="1">
                 <a:solidFill>
                   <a:srgbClr val="535766"/>
@@ -6769,10 +7240,16 @@
           </a:fontRef>
         </p:style>
         <p:txBody>
-          <a:bodyPr rtlCol="0" anchor="ctr"/>
+          <a:bodyPr rtlCol="0" anchor="ctr" lIns="18288" rIns="18288" tIns="18288" bIns="18288"/>
           <a:lstStyle/>
           <a:p>
             <a:pPr algn="ctr">
+              <a:spcBef>
+                <a:spcPts val="0"/>
+              </a:spcBef>
+              <a:spcAft>
+                <a:spcPts val="0"/>
+              </a:spcAft>
               <a:defRPr sz="900" b="1">
                 <a:solidFill>
                   <a:srgbClr val="535766"/>
@@ -6839,10 +7316,16 @@
           </a:fontRef>
         </p:style>
         <p:txBody>
-          <a:bodyPr rtlCol="0" anchor="ctr" wrap="square"/>
+          <a:bodyPr rtlCol="0" anchor="ctr" wrap="square" tIns="18288" bIns="18288"/>
           <a:lstStyle/>
           <a:p>
             <a:pPr algn="ctr">
+              <a:spcBef>
+                <a:spcPts val="0"/>
+              </a:spcBef>
+              <a:spcAft>
+                <a:spcPts val="0"/>
+              </a:spcAft>
               <a:defRPr sz="1000" b="1">
                 <a:solidFill>
                   <a:srgbClr val="FFFFFF"/>
@@ -6872,13 +7355,16 @@
           <a:noFill/>
         </p:spPr>
         <p:txBody>
-          <a:bodyPr wrap="square">
+          <a:bodyPr wrap="square" lIns="0" rIns="0" tIns="0" bIns="0">
             <a:spAutoFit/>
           </a:bodyPr>
           <a:lstStyle/>
           <a:p>
             <a:pPr>
-              <a:defRPr sz="1450" b="1">
+              <a:spcAft>
+                <a:spcPts val="300"/>
+              </a:spcAft>
+              <a:defRPr sz="1400" b="1">
                 <a:solidFill>
                   <a:srgbClr val="282C3F"/>
                 </a:solidFill>
@@ -6890,7 +7376,13 @@
           </a:p>
           <a:p>
             <a:pPr>
-              <a:defRPr sz="1150" b="1">
+              <a:spcBef>
+                <a:spcPts val="200"/>
+              </a:spcBef>
+              <a:spcAft>
+                <a:spcPts val="400"/>
+              </a:spcAft>
+              <a:defRPr sz="1050" b="1">
                 <a:solidFill>
                   <a:srgbClr val="FF3F6C"/>
                 </a:solidFill>
@@ -6919,7 +7411,7 @@
           <a:noFill/>
         </p:spPr>
         <p:txBody>
-          <a:bodyPr wrap="none">
+          <a:bodyPr wrap="none" lIns="0" rIns="0" tIns="0" bIns="0">
             <a:spAutoFit/>
           </a:bodyPr>
           <a:lstStyle/>
@@ -6990,8 +7482,8 @@
         </p:nvSpPr>
         <p:spPr>
           <a:xfrm>
-            <a:off x="777240" y="1783080"/>
-            <a:ext cx="5029200" cy="3520440"/>
+            <a:off x="749808" y="1755648"/>
+            <a:ext cx="5084064" cy="3575304"/>
           </a:xfrm>
           <a:prstGeom prst="rect">
             <a:avLst/>
@@ -6999,12 +7491,15 @@
           <a:noFill/>
         </p:spPr>
         <p:txBody>
-          <a:bodyPr wrap="square">
+          <a:bodyPr wrap="square" tIns="73152" bIns="73152">
             <a:spAutoFit/>
           </a:bodyPr>
           <a:lstStyle/>
           <a:p>
             <a:pPr>
+              <a:spcAft>
+                <a:spcPts val="800"/>
+              </a:spcAft>
               <a:defRPr sz="1100" b="1">
                 <a:solidFill>
                   <a:srgbClr val="FF3F6C"/>
@@ -7017,6 +7512,12 @@
           </a:p>
           <a:p>
             <a:pPr>
+              <a:spcBef>
+                <a:spcPts val="400"/>
+              </a:spcBef>
+              <a:spcAft>
+                <a:spcPts val="100"/>
+              </a:spcAft>
               <a:defRPr sz="1000"/>
             </a:pPr>
             <a:r>
@@ -7025,9 +7526,22 @@
                   <a:srgbClr val="FF3F6C"/>
                 </a:solidFill>
               </a:rPr>
-              <a:t>► 1. Initial Hypothesis
-</a:t>
-            </a:r>
+              <a:t>► 1. Initial Hypothesis</a:t>
+            </a:r>
+          </a:p>
+          <a:p>
+            <a:pPr>
+              <a:lnSpc>
+                <a:spcPct val="115000"/>
+              </a:lnSpc>
+              <a:spcBef>
+                <a:spcPts val="0"/>
+              </a:spcBef>
+              <a:spcAft>
+                <a:spcPts val="600"/>
+              </a:spcAft>
+              <a:defRPr sz="950"/>
+            </a:pPr>
             <a:r>
               <a:rPr>
                 <a:solidFill>
@@ -7039,6 +7553,12 @@
           </a:p>
           <a:p>
             <a:pPr>
+              <a:spcBef>
+                <a:spcPts val="400"/>
+              </a:spcBef>
+              <a:spcAft>
+                <a:spcPts val="100"/>
+              </a:spcAft>
               <a:defRPr sz="1000"/>
             </a:pPr>
             <a:r>
@@ -7047,9 +7567,22 @@
                   <a:srgbClr val="FF3F6C"/>
                 </a:solidFill>
               </a:rPr>
-              <a:t>► 2. Sourced 20,250 Review NLP
-</a:t>
-            </a:r>
+              <a:t>► 2. Sourced 20,250 Review NLP</a:t>
+            </a:r>
+          </a:p>
+          <a:p>
+            <a:pPr>
+              <a:lnSpc>
+                <a:spcPct val="115000"/>
+              </a:lnSpc>
+              <a:spcBef>
+                <a:spcPts val="0"/>
+              </a:spcBef>
+              <a:spcAft>
+                <a:spcPts val="600"/>
+              </a:spcAft>
+              <a:defRPr sz="950"/>
+            </a:pPr>
             <a:r>
               <a:rPr>
                 <a:solidFill>
@@ -7061,6 +7594,12 @@
           </a:p>
           <a:p>
             <a:pPr>
+              <a:spcBef>
+                <a:spcPts val="400"/>
+              </a:spcBef>
+              <a:spcAft>
+                <a:spcPts val="100"/>
+              </a:spcAft>
               <a:defRPr sz="1000"/>
             </a:pPr>
             <a:r>
@@ -7069,9 +7608,22 @@
                   <a:srgbClr val="FF3F6C"/>
                 </a:solidFill>
               </a:rPr>
-              <a:t>► 3. Primary Interview Pivot (N=9)
-</a:t>
-            </a:r>
+              <a:t>► 3. Primary Interview Pivot (N=9)</a:t>
+            </a:r>
+          </a:p>
+          <a:p>
+            <a:pPr>
+              <a:lnSpc>
+                <a:spcPct val="115000"/>
+              </a:lnSpc>
+              <a:spcBef>
+                <a:spcPts val="0"/>
+              </a:spcBef>
+              <a:spcAft>
+                <a:spcPts val="600"/>
+              </a:spcAft>
+              <a:defRPr sz="950"/>
+            </a:pPr>
             <a:r>
               <a:rPr>
                 <a:solidFill>
@@ -7083,6 +7635,12 @@
           </a:p>
           <a:p>
             <a:pPr>
+              <a:spcBef>
+                <a:spcPts val="400"/>
+              </a:spcBef>
+              <a:spcAft>
+                <a:spcPts val="100"/>
+              </a:spcAft>
               <a:defRPr sz="1000"/>
             </a:pPr>
             <a:r>
@@ -7091,9 +7649,22 @@
                   <a:srgbClr val="FF3F6C"/>
                 </a:solidFill>
               </a:rPr>
-              <a:t>► 4. Core Problem Definition
-</a:t>
-            </a:r>
+              <a:t>► 4. Core Problem Definition</a:t>
+            </a:r>
+          </a:p>
+          <a:p>
+            <a:pPr>
+              <a:lnSpc>
+                <a:spcPct val="115000"/>
+              </a:lnSpc>
+              <a:spcBef>
+                <a:spcPts val="0"/>
+              </a:spcBef>
+              <a:spcAft>
+                <a:spcPts val="600"/>
+              </a:spcAft>
+              <a:defRPr sz="950"/>
+            </a:pPr>
             <a:r>
               <a:rPr>
                 <a:solidFill>
@@ -7158,8 +7729,8 @@
         </p:nvSpPr>
         <p:spPr>
           <a:xfrm>
-            <a:off x="6355080" y="1783080"/>
-            <a:ext cx="5029200" cy="3520440"/>
+            <a:off x="6327648" y="1755648"/>
+            <a:ext cx="5084064" cy="3575304"/>
           </a:xfrm>
           <a:prstGeom prst="rect">
             <a:avLst/>
@@ -7167,12 +7738,15 @@
           <a:noFill/>
         </p:spPr>
         <p:txBody>
-          <a:bodyPr wrap="square">
+          <a:bodyPr wrap="square" tIns="73152" bIns="73152">
             <a:spAutoFit/>
           </a:bodyPr>
           <a:lstStyle/>
           <a:p>
             <a:pPr>
+              <a:spcAft>
+                <a:spcPts val="800"/>
+              </a:spcAft>
               <a:defRPr sz="1100" b="1">
                 <a:solidFill>
                   <a:srgbClr val="FF3F6C"/>
@@ -7185,7 +7759,16 @@
           </a:p>
           <a:p>
             <a:pPr>
-              <a:defRPr sz="1000"/>
+              <a:lnSpc>
+                <a:spcPct val="118000"/>
+              </a:lnSpc>
+              <a:spcBef>
+                <a:spcPts val="300"/>
+              </a:spcBef>
+              <a:spcAft>
+                <a:spcPts val="600"/>
+              </a:spcAft>
+              <a:defRPr sz="950"/>
             </a:pPr>
             <a:r>
               <a:rPr b="1">
@@ -7206,7 +7789,16 @@
           </a:p>
           <a:p>
             <a:pPr>
-              <a:defRPr sz="1000"/>
+              <a:lnSpc>
+                <a:spcPct val="118000"/>
+              </a:lnSpc>
+              <a:spcBef>
+                <a:spcPts val="300"/>
+              </a:spcBef>
+              <a:spcAft>
+                <a:spcPts val="600"/>
+              </a:spcAft>
+              <a:defRPr sz="950"/>
             </a:pPr>
             <a:r>
               <a:rPr b="1">
@@ -7227,7 +7819,16 @@
           </a:p>
           <a:p>
             <a:pPr>
-              <a:defRPr sz="1000"/>
+              <a:lnSpc>
+                <a:spcPct val="118000"/>
+              </a:lnSpc>
+              <a:spcBef>
+                <a:spcPts val="300"/>
+              </a:spcBef>
+              <a:spcAft>
+                <a:spcPts val="600"/>
+              </a:spcAft>
+              <a:defRPr sz="950"/>
             </a:pPr>
             <a:r>
               <a:rPr b="1">
@@ -7248,7 +7849,16 @@
           </a:p>
           <a:p>
             <a:pPr>
-              <a:defRPr sz="1000"/>
+              <a:lnSpc>
+                <a:spcPct val="118000"/>
+              </a:lnSpc>
+              <a:spcBef>
+                <a:spcPts val="300"/>
+              </a:spcBef>
+              <a:spcAft>
+                <a:spcPts val="600"/>
+              </a:spcAft>
+              <a:defRPr sz="950"/>
             </a:pPr>
             <a:r>
               <a:rPr b="1">
@@ -7322,8 +7932,8 @@
         </p:nvSpPr>
         <p:spPr>
           <a:xfrm>
-            <a:off x="777240" y="5605272"/>
-            <a:ext cx="10637215" cy="493776"/>
+            <a:off x="777240" y="5586984"/>
+            <a:ext cx="10637215" cy="530352"/>
           </a:xfrm>
           <a:prstGeom prst="rect">
             <a:avLst/>
@@ -7331,13 +7941,16 @@
           <a:noFill/>
         </p:spPr>
         <p:txBody>
-          <a:bodyPr wrap="square">
+          <a:bodyPr wrap="square" tIns="36576" bIns="36576">
             <a:spAutoFit/>
           </a:bodyPr>
           <a:lstStyle/>
           <a:p>
             <a:pPr>
-              <a:defRPr sz="1000" b="1">
+              <a:spcAft>
+                <a:spcPts val="200"/>
+              </a:spcAft>
+              <a:defRPr sz="950" b="1">
                 <a:solidFill>
                   <a:srgbClr val="4338CA"/>
                 </a:solidFill>
@@ -7349,7 +7962,13 @@
           </a:p>
           <a:p>
             <a:pPr>
-              <a:defRPr sz="1000" b="1">
+              <a:lnSpc>
+                <a:spcPct val="115000"/>
+              </a:lnSpc>
+              <a:spcBef>
+                <a:spcPts val="0"/>
+              </a:spcBef>
+              <a:defRPr sz="950" b="1">
                 <a:solidFill>
                   <a:srgbClr val="282C3F"/>
                 </a:solidFill>
@@ -7399,10 +8018,16 @@
           </a:fontRef>
         </p:style>
         <p:txBody>
-          <a:bodyPr rtlCol="0" anchor="ctr"/>
+          <a:bodyPr rtlCol="0" anchor="ctr" lIns="18288" rIns="18288" tIns="18288" bIns="18288"/>
           <a:lstStyle/>
           <a:p>
             <a:pPr algn="ctr">
+              <a:spcBef>
+                <a:spcPts val="0"/>
+              </a:spcBef>
+              <a:spcAft>
+                <a:spcPts val="0"/>
+              </a:spcAft>
               <a:defRPr sz="900" b="1">
                 <a:solidFill>
                   <a:srgbClr val="535766"/>
@@ -7453,10 +8078,16 @@
           </a:fontRef>
         </p:style>
         <p:txBody>
-          <a:bodyPr rtlCol="0" anchor="ctr"/>
+          <a:bodyPr rtlCol="0" anchor="ctr" lIns="18288" rIns="18288" tIns="18288" bIns="18288"/>
           <a:lstStyle/>
           <a:p>
             <a:pPr algn="ctr">
+              <a:spcBef>
+                <a:spcPts val="0"/>
+              </a:spcBef>
+              <a:spcAft>
+                <a:spcPts val="0"/>
+              </a:spcAft>
               <a:defRPr sz="900" b="1">
                 <a:solidFill>
                   <a:srgbClr val="535766"/>
@@ -7507,10 +8138,16 @@
           </a:fontRef>
         </p:style>
         <p:txBody>
-          <a:bodyPr rtlCol="0" anchor="ctr"/>
+          <a:bodyPr rtlCol="0" anchor="ctr" lIns="18288" rIns="18288" tIns="18288" bIns="18288"/>
           <a:lstStyle/>
           <a:p>
             <a:pPr algn="ctr">
+              <a:spcBef>
+                <a:spcPts val="0"/>
+              </a:spcBef>
+              <a:spcAft>
+                <a:spcPts val="0"/>
+              </a:spcAft>
               <a:defRPr sz="900" b="1">
                 <a:solidFill>
                   <a:srgbClr val="FFFFFF"/>
@@ -7561,10 +8198,16 @@
           </a:fontRef>
         </p:style>
         <p:txBody>
-          <a:bodyPr rtlCol="0" anchor="ctr"/>
+          <a:bodyPr rtlCol="0" anchor="ctr" lIns="18288" rIns="18288" tIns="18288" bIns="18288"/>
           <a:lstStyle/>
           <a:p>
             <a:pPr algn="ctr">
+              <a:spcBef>
+                <a:spcPts val="0"/>
+              </a:spcBef>
+              <a:spcAft>
+                <a:spcPts val="0"/>
+              </a:spcAft>
               <a:defRPr sz="900" b="1">
                 <a:solidFill>
                   <a:srgbClr val="535766"/>
@@ -7615,10 +8258,16 @@
           </a:fontRef>
         </p:style>
         <p:txBody>
-          <a:bodyPr rtlCol="0" anchor="ctr"/>
+          <a:bodyPr rtlCol="0" anchor="ctr" lIns="18288" rIns="18288" tIns="18288" bIns="18288"/>
           <a:lstStyle/>
           <a:p>
             <a:pPr algn="ctr">
+              <a:spcBef>
+                <a:spcPts val="0"/>
+              </a:spcBef>
+              <a:spcAft>
+                <a:spcPts val="0"/>
+              </a:spcAft>
               <a:defRPr sz="900" b="1">
                 <a:solidFill>
                   <a:srgbClr val="535766"/>
@@ -7669,10 +8318,16 @@
           </a:fontRef>
         </p:style>
         <p:txBody>
-          <a:bodyPr rtlCol="0" anchor="ctr"/>
+          <a:bodyPr rtlCol="0" anchor="ctr" lIns="18288" rIns="18288" tIns="18288" bIns="18288"/>
           <a:lstStyle/>
           <a:p>
             <a:pPr algn="ctr">
+              <a:spcBef>
+                <a:spcPts val="0"/>
+              </a:spcBef>
+              <a:spcAft>
+                <a:spcPts val="0"/>
+              </a:spcAft>
               <a:defRPr sz="900" b="1">
                 <a:solidFill>
                   <a:srgbClr val="535766"/>
@@ -7723,10 +8378,16 @@
           </a:fontRef>
         </p:style>
         <p:txBody>
-          <a:bodyPr rtlCol="0" anchor="ctr"/>
+          <a:bodyPr rtlCol="0" anchor="ctr" lIns="18288" rIns="18288" tIns="18288" bIns="18288"/>
           <a:lstStyle/>
           <a:p>
             <a:pPr algn="ctr">
+              <a:spcBef>
+                <a:spcPts val="0"/>
+              </a:spcBef>
+              <a:spcAft>
+                <a:spcPts val="0"/>
+              </a:spcAft>
               <a:defRPr sz="900" b="1">
                 <a:solidFill>
                   <a:srgbClr val="535766"/>
@@ -7777,10 +8438,16 @@
           </a:fontRef>
         </p:style>
         <p:txBody>
-          <a:bodyPr rtlCol="0" anchor="ctr"/>
+          <a:bodyPr rtlCol="0" anchor="ctr" lIns="18288" rIns="18288" tIns="18288" bIns="18288"/>
           <a:lstStyle/>
           <a:p>
             <a:pPr algn="ctr">
+              <a:spcBef>
+                <a:spcPts val="0"/>
+              </a:spcBef>
+              <a:spcAft>
+                <a:spcPts val="0"/>
+              </a:spcAft>
               <a:defRPr sz="900" b="1">
                 <a:solidFill>
                   <a:srgbClr val="535766"/>
@@ -7831,10 +8498,16 @@
           </a:fontRef>
         </p:style>
         <p:txBody>
-          <a:bodyPr rtlCol="0" anchor="ctr"/>
+          <a:bodyPr rtlCol="0" anchor="ctr" lIns="18288" rIns="18288" tIns="18288" bIns="18288"/>
           <a:lstStyle/>
           <a:p>
             <a:pPr algn="ctr">
+              <a:spcBef>
+                <a:spcPts val="0"/>
+              </a:spcBef>
+              <a:spcAft>
+                <a:spcPts val="0"/>
+              </a:spcAft>
               <a:defRPr sz="900" b="1">
                 <a:solidFill>
                   <a:srgbClr val="535766"/>
@@ -7885,10 +8558,16 @@
           </a:fontRef>
         </p:style>
         <p:txBody>
-          <a:bodyPr rtlCol="0" anchor="ctr"/>
+          <a:bodyPr rtlCol="0" anchor="ctr" lIns="18288" rIns="18288" tIns="18288" bIns="18288"/>
           <a:lstStyle/>
           <a:p>
             <a:pPr algn="ctr">
+              <a:spcBef>
+                <a:spcPts val="0"/>
+              </a:spcBef>
+              <a:spcAft>
+                <a:spcPts val="0"/>
+              </a:spcAft>
               <a:defRPr sz="900" b="1">
                 <a:solidFill>
                   <a:srgbClr val="535766"/>
@@ -7955,10 +8634,16 @@
           </a:fontRef>
         </p:style>
         <p:txBody>
-          <a:bodyPr rtlCol="0" anchor="ctr" wrap="square"/>
+          <a:bodyPr rtlCol="0" anchor="ctr" wrap="square" tIns="18288" bIns="18288"/>
           <a:lstStyle/>
           <a:p>
             <a:pPr algn="ctr">
+              <a:spcBef>
+                <a:spcPts val="0"/>
+              </a:spcBef>
+              <a:spcAft>
+                <a:spcPts val="0"/>
+              </a:spcAft>
               <a:defRPr sz="1000" b="1">
                 <a:solidFill>
                   <a:srgbClr val="FFFFFF"/>
@@ -7988,13 +8673,16 @@
           <a:noFill/>
         </p:spPr>
         <p:txBody>
-          <a:bodyPr wrap="square">
+          <a:bodyPr wrap="square" lIns="0" rIns="0" tIns="0" bIns="0">
             <a:spAutoFit/>
           </a:bodyPr>
           <a:lstStyle/>
           <a:p>
             <a:pPr>
-              <a:defRPr sz="1450" b="1">
+              <a:spcAft>
+                <a:spcPts val="300"/>
+              </a:spcAft>
+              <a:defRPr sz="1400" b="1">
                 <a:solidFill>
                   <a:srgbClr val="282C3F"/>
                 </a:solidFill>
@@ -8006,7 +8694,13 @@
           </a:p>
           <a:p>
             <a:pPr>
-              <a:defRPr sz="1150" b="1">
+              <a:spcBef>
+                <a:spcPts val="200"/>
+              </a:spcBef>
+              <a:spcAft>
+                <a:spcPts val="400"/>
+              </a:spcAft>
+              <a:defRPr sz="1050" b="1">
                 <a:solidFill>
                   <a:srgbClr val="FF3F6C"/>
                 </a:solidFill>
@@ -8035,7 +8729,7 @@
           <a:noFill/>
         </p:spPr>
         <p:txBody>
-          <a:bodyPr wrap="none">
+          <a:bodyPr wrap="none" lIns="0" rIns="0" tIns="0" bIns="0">
             <a:spAutoFit/>
           </a:bodyPr>
           <a:lstStyle/>
@@ -8106,8 +8800,8 @@
         </p:nvSpPr>
         <p:spPr>
           <a:xfrm>
-            <a:off x="777240" y="1783080"/>
-            <a:ext cx="3840480" cy="3520440"/>
+            <a:off x="749808" y="1755648"/>
+            <a:ext cx="3895344" cy="3575304"/>
           </a:xfrm>
           <a:prstGeom prst="rect">
             <a:avLst/>
@@ -8115,12 +8809,15 @@
           <a:noFill/>
         </p:spPr>
         <p:txBody>
-          <a:bodyPr wrap="square">
+          <a:bodyPr wrap="square" tIns="73152" bIns="73152">
             <a:spAutoFit/>
           </a:bodyPr>
           <a:lstStyle/>
           <a:p>
             <a:pPr>
+              <a:spcAft>
+                <a:spcPts val="800"/>
+              </a:spcAft>
               <a:defRPr sz="1100" b="1">
                 <a:solidFill>
                   <a:srgbClr val="FF3F6C"/>
@@ -8133,7 +8830,16 @@
           </a:p>
           <a:p>
             <a:pPr>
-              <a:defRPr sz="1000"/>
+              <a:lnSpc>
+                <a:spcPct val="118000"/>
+              </a:lnSpc>
+              <a:spcBef>
+                <a:spcPts val="200"/>
+              </a:spcBef>
+              <a:spcAft>
+                <a:spcPts val="500"/>
+              </a:spcAft>
+              <a:defRPr sz="950"/>
             </a:pPr>
             <a:r>
               <a:rPr b="1">
@@ -8162,7 +8868,16 @@
           </a:p>
           <a:p>
             <a:pPr>
-              <a:defRPr sz="1000"/>
+              <a:lnSpc>
+                <a:spcPct val="118000"/>
+              </a:lnSpc>
+              <a:spcBef>
+                <a:spcPts val="200"/>
+              </a:spcBef>
+              <a:spcAft>
+                <a:spcPts val="500"/>
+              </a:spcAft>
+              <a:defRPr sz="950"/>
             </a:pPr>
             <a:r>
               <a:rPr b="1">
@@ -8191,7 +8906,16 @@
           </a:p>
           <a:p>
             <a:pPr>
-              <a:defRPr sz="1000"/>
+              <a:lnSpc>
+                <a:spcPct val="118000"/>
+              </a:lnSpc>
+              <a:spcBef>
+                <a:spcPts val="200"/>
+              </a:spcBef>
+              <a:spcAft>
+                <a:spcPts val="500"/>
+              </a:spcAft>
+              <a:defRPr sz="950"/>
             </a:pPr>
             <a:r>
               <a:rPr b="1">
@@ -8220,7 +8944,16 @@
           </a:p>
           <a:p>
             <a:pPr>
-              <a:defRPr sz="1000"/>
+              <a:lnSpc>
+                <a:spcPct val="118000"/>
+              </a:lnSpc>
+              <a:spcBef>
+                <a:spcPts val="200"/>
+              </a:spcBef>
+              <a:spcAft>
+                <a:spcPts val="500"/>
+              </a:spcAft>
+              <a:defRPr sz="950"/>
             </a:pPr>
             <a:r>
               <a:rPr b="1">
@@ -8302,8 +9035,8 @@
         </p:nvSpPr>
         <p:spPr>
           <a:xfrm>
-            <a:off x="5029200" y="1783080"/>
-            <a:ext cx="3840480" cy="3520440"/>
+            <a:off x="5001768" y="1755648"/>
+            <a:ext cx="3895344" cy="3575304"/>
           </a:xfrm>
           <a:prstGeom prst="rect">
             <a:avLst/>
@@ -8311,12 +9044,15 @@
           <a:noFill/>
         </p:spPr>
         <p:txBody>
-          <a:bodyPr wrap="square">
+          <a:bodyPr wrap="square" tIns="73152" bIns="73152">
             <a:spAutoFit/>
           </a:bodyPr>
           <a:lstStyle/>
           <a:p>
             <a:pPr>
+              <a:spcAft>
+                <a:spcPts val="800"/>
+              </a:spcAft>
               <a:defRPr sz="1100" b="1">
                 <a:solidFill>
                   <a:srgbClr val="FF3F6C"/>
@@ -8329,7 +9065,16 @@
           </a:p>
           <a:p>
             <a:pPr>
-              <a:defRPr sz="1000"/>
+              <a:lnSpc>
+                <a:spcPct val="118000"/>
+              </a:lnSpc>
+              <a:spcBef>
+                <a:spcPts val="200"/>
+              </a:spcBef>
+              <a:spcAft>
+                <a:spcPts val="500"/>
+              </a:spcAft>
+              <a:defRPr sz="950"/>
             </a:pPr>
             <a:r>
               <a:rPr b="1">
@@ -8358,7 +9103,16 @@
           </a:p>
           <a:p>
             <a:pPr>
-              <a:defRPr sz="1000"/>
+              <a:lnSpc>
+                <a:spcPct val="118000"/>
+              </a:lnSpc>
+              <a:spcBef>
+                <a:spcPts val="200"/>
+              </a:spcBef>
+              <a:spcAft>
+                <a:spcPts val="500"/>
+              </a:spcAft>
+              <a:defRPr sz="950"/>
             </a:pPr>
             <a:r>
               <a:rPr b="1">
@@ -8387,7 +9141,16 @@
           </a:p>
           <a:p>
             <a:pPr>
-              <a:defRPr sz="1000"/>
+              <a:lnSpc>
+                <a:spcPct val="118000"/>
+              </a:lnSpc>
+              <a:spcBef>
+                <a:spcPts val="200"/>
+              </a:spcBef>
+              <a:spcAft>
+                <a:spcPts val="500"/>
+              </a:spcAft>
+              <a:defRPr sz="950"/>
             </a:pPr>
             <a:r>
               <a:rPr b="1">
@@ -8416,7 +9179,16 @@
           </a:p>
           <a:p>
             <a:pPr>
-              <a:defRPr sz="1000"/>
+              <a:lnSpc>
+                <a:spcPct val="118000"/>
+              </a:lnSpc>
+              <a:spcBef>
+                <a:spcPts val="200"/>
+              </a:spcBef>
+              <a:spcAft>
+                <a:spcPts val="500"/>
+              </a:spcAft>
+              <a:defRPr sz="950"/>
             </a:pPr>
             <a:r>
               <a:rPr b="1">
@@ -8567,8 +9339,8 @@
         </p:nvSpPr>
         <p:spPr>
           <a:xfrm>
-            <a:off x="777240" y="5605272"/>
-            <a:ext cx="10637215" cy="493776"/>
+            <a:off x="777240" y="5586984"/>
+            <a:ext cx="10637215" cy="530352"/>
           </a:xfrm>
           <a:prstGeom prst="rect">
             <a:avLst/>
@@ -8576,13 +9348,16 @@
           <a:noFill/>
         </p:spPr>
         <p:txBody>
-          <a:bodyPr wrap="square">
+          <a:bodyPr wrap="square" tIns="36576" bIns="36576">
             <a:spAutoFit/>
           </a:bodyPr>
           <a:lstStyle/>
           <a:p>
             <a:pPr>
-              <a:defRPr sz="1000" b="1">
+              <a:spcAft>
+                <a:spcPts val="200"/>
+              </a:spcAft>
+              <a:defRPr sz="950" b="1">
                 <a:solidFill>
                   <a:srgbClr val="4338CA"/>
                 </a:solidFill>
@@ -8594,7 +9369,13 @@
           </a:p>
           <a:p>
             <a:pPr>
-              <a:defRPr sz="1000" b="1">
+              <a:lnSpc>
+                <a:spcPct val="115000"/>
+              </a:lnSpc>
+              <a:spcBef>
+                <a:spcPts val="0"/>
+              </a:spcBef>
+              <a:defRPr sz="950" b="1">
                 <a:solidFill>
                   <a:srgbClr val="282C3F"/>
                 </a:solidFill>
@@ -8644,10 +9425,16 @@
           </a:fontRef>
         </p:style>
         <p:txBody>
-          <a:bodyPr rtlCol="0" anchor="ctr"/>
+          <a:bodyPr rtlCol="0" anchor="ctr" lIns="18288" rIns="18288" tIns="18288" bIns="18288"/>
           <a:lstStyle/>
           <a:p>
             <a:pPr algn="ctr">
+              <a:spcBef>
+                <a:spcPts val="0"/>
+              </a:spcBef>
+              <a:spcAft>
+                <a:spcPts val="0"/>
+              </a:spcAft>
               <a:defRPr sz="900" b="1">
                 <a:solidFill>
                   <a:srgbClr val="535766"/>
@@ -8698,10 +9485,16 @@
           </a:fontRef>
         </p:style>
         <p:txBody>
-          <a:bodyPr rtlCol="0" anchor="ctr"/>
+          <a:bodyPr rtlCol="0" anchor="ctr" lIns="18288" rIns="18288" tIns="18288" bIns="18288"/>
           <a:lstStyle/>
           <a:p>
             <a:pPr algn="ctr">
+              <a:spcBef>
+                <a:spcPts val="0"/>
+              </a:spcBef>
+              <a:spcAft>
+                <a:spcPts val="0"/>
+              </a:spcAft>
               <a:defRPr sz="900" b="1">
                 <a:solidFill>
                   <a:srgbClr val="535766"/>
@@ -8752,10 +9545,16 @@
           </a:fontRef>
         </p:style>
         <p:txBody>
-          <a:bodyPr rtlCol="0" anchor="ctr"/>
+          <a:bodyPr rtlCol="0" anchor="ctr" lIns="18288" rIns="18288" tIns="18288" bIns="18288"/>
           <a:lstStyle/>
           <a:p>
             <a:pPr algn="ctr">
+              <a:spcBef>
+                <a:spcPts val="0"/>
+              </a:spcBef>
+              <a:spcAft>
+                <a:spcPts val="0"/>
+              </a:spcAft>
               <a:defRPr sz="900" b="1">
                 <a:solidFill>
                   <a:srgbClr val="535766"/>
@@ -8806,10 +9605,16 @@
           </a:fontRef>
         </p:style>
         <p:txBody>
-          <a:bodyPr rtlCol="0" anchor="ctr"/>
+          <a:bodyPr rtlCol="0" anchor="ctr" lIns="18288" rIns="18288" tIns="18288" bIns="18288"/>
           <a:lstStyle/>
           <a:p>
             <a:pPr algn="ctr">
+              <a:spcBef>
+                <a:spcPts val="0"/>
+              </a:spcBef>
+              <a:spcAft>
+                <a:spcPts val="0"/>
+              </a:spcAft>
               <a:defRPr sz="900" b="1">
                 <a:solidFill>
                   <a:srgbClr val="FFFFFF"/>
@@ -8860,10 +9665,16 @@
           </a:fontRef>
         </p:style>
         <p:txBody>
-          <a:bodyPr rtlCol="0" anchor="ctr"/>
+          <a:bodyPr rtlCol="0" anchor="ctr" lIns="18288" rIns="18288" tIns="18288" bIns="18288"/>
           <a:lstStyle/>
           <a:p>
             <a:pPr algn="ctr">
+              <a:spcBef>
+                <a:spcPts val="0"/>
+              </a:spcBef>
+              <a:spcAft>
+                <a:spcPts val="0"/>
+              </a:spcAft>
               <a:defRPr sz="900" b="1">
                 <a:solidFill>
                   <a:srgbClr val="535766"/>
@@ -8914,10 +9725,16 @@
           </a:fontRef>
         </p:style>
         <p:txBody>
-          <a:bodyPr rtlCol="0" anchor="ctr"/>
+          <a:bodyPr rtlCol="0" anchor="ctr" lIns="18288" rIns="18288" tIns="18288" bIns="18288"/>
           <a:lstStyle/>
           <a:p>
             <a:pPr algn="ctr">
+              <a:spcBef>
+                <a:spcPts val="0"/>
+              </a:spcBef>
+              <a:spcAft>
+                <a:spcPts val="0"/>
+              </a:spcAft>
               <a:defRPr sz="900" b="1">
                 <a:solidFill>
                   <a:srgbClr val="535766"/>
@@ -8968,10 +9785,16 @@
           </a:fontRef>
         </p:style>
         <p:txBody>
-          <a:bodyPr rtlCol="0" anchor="ctr"/>
+          <a:bodyPr rtlCol="0" anchor="ctr" lIns="18288" rIns="18288" tIns="18288" bIns="18288"/>
           <a:lstStyle/>
           <a:p>
             <a:pPr algn="ctr">
+              <a:spcBef>
+                <a:spcPts val="0"/>
+              </a:spcBef>
+              <a:spcAft>
+                <a:spcPts val="0"/>
+              </a:spcAft>
               <a:defRPr sz="900" b="1">
                 <a:solidFill>
                   <a:srgbClr val="535766"/>
@@ -9022,10 +9845,16 @@
           </a:fontRef>
         </p:style>
         <p:txBody>
-          <a:bodyPr rtlCol="0" anchor="ctr"/>
+          <a:bodyPr rtlCol="0" anchor="ctr" lIns="18288" rIns="18288" tIns="18288" bIns="18288"/>
           <a:lstStyle/>
           <a:p>
             <a:pPr algn="ctr">
+              <a:spcBef>
+                <a:spcPts val="0"/>
+              </a:spcBef>
+              <a:spcAft>
+                <a:spcPts val="0"/>
+              </a:spcAft>
               <a:defRPr sz="900" b="1">
                 <a:solidFill>
                   <a:srgbClr val="535766"/>
@@ -9076,10 +9905,16 @@
           </a:fontRef>
         </p:style>
         <p:txBody>
-          <a:bodyPr rtlCol="0" anchor="ctr"/>
+          <a:bodyPr rtlCol="0" anchor="ctr" lIns="18288" rIns="18288" tIns="18288" bIns="18288"/>
           <a:lstStyle/>
           <a:p>
             <a:pPr algn="ctr">
+              <a:spcBef>
+                <a:spcPts val="0"/>
+              </a:spcBef>
+              <a:spcAft>
+                <a:spcPts val="0"/>
+              </a:spcAft>
               <a:defRPr sz="900" b="1">
                 <a:solidFill>
                   <a:srgbClr val="535766"/>
@@ -9130,10 +9965,16 @@
           </a:fontRef>
         </p:style>
         <p:txBody>
-          <a:bodyPr rtlCol="0" anchor="ctr"/>
+          <a:bodyPr rtlCol="0" anchor="ctr" lIns="18288" rIns="18288" tIns="18288" bIns="18288"/>
           <a:lstStyle/>
           <a:p>
             <a:pPr algn="ctr">
+              <a:spcBef>
+                <a:spcPts val="0"/>
+              </a:spcBef>
+              <a:spcAft>
+                <a:spcPts val="0"/>
+              </a:spcAft>
               <a:defRPr sz="900" b="1">
                 <a:solidFill>
                   <a:srgbClr val="535766"/>
@@ -9200,10 +10041,16 @@
           </a:fontRef>
         </p:style>
         <p:txBody>
-          <a:bodyPr rtlCol="0" anchor="ctr" wrap="square"/>
+          <a:bodyPr rtlCol="0" anchor="ctr" wrap="square" tIns="18288" bIns="18288"/>
           <a:lstStyle/>
           <a:p>
             <a:pPr algn="ctr">
+              <a:spcBef>
+                <a:spcPts val="0"/>
+              </a:spcBef>
+              <a:spcAft>
+                <a:spcPts val="0"/>
+              </a:spcAft>
               <a:defRPr sz="1000" b="1">
                 <a:solidFill>
                   <a:srgbClr val="FFFFFF"/>
@@ -9233,13 +10080,16 @@
           <a:noFill/>
         </p:spPr>
         <p:txBody>
-          <a:bodyPr wrap="square">
+          <a:bodyPr wrap="square" lIns="0" rIns="0" tIns="0" bIns="0">
             <a:spAutoFit/>
           </a:bodyPr>
           <a:lstStyle/>
           <a:p>
             <a:pPr>
-              <a:defRPr sz="1450" b="1">
+              <a:spcAft>
+                <a:spcPts val="300"/>
+              </a:spcAft>
+              <a:defRPr sz="1400" b="1">
                 <a:solidFill>
                   <a:srgbClr val="282C3F"/>
                 </a:solidFill>
@@ -9251,7 +10101,13 @@
           </a:p>
           <a:p>
             <a:pPr>
-              <a:defRPr sz="1150" b="1">
+              <a:spcBef>
+                <a:spcPts val="200"/>
+              </a:spcBef>
+              <a:spcAft>
+                <a:spcPts val="400"/>
+              </a:spcAft>
+              <a:defRPr sz="1050" b="1">
                 <a:solidFill>
                   <a:srgbClr val="FF3F6C"/>
                 </a:solidFill>
@@ -9280,7 +10136,7 @@
           <a:noFill/>
         </p:spPr>
         <p:txBody>
-          <a:bodyPr wrap="none">
+          <a:bodyPr wrap="none" lIns="0" rIns="0" tIns="0" bIns="0">
             <a:spAutoFit/>
           </a:bodyPr>
           <a:lstStyle/>
@@ -9351,8 +10207,8 @@
         </p:nvSpPr>
         <p:spPr>
           <a:xfrm>
-            <a:off x="777240" y="1783080"/>
-            <a:ext cx="5029200" cy="3520440"/>
+            <a:off x="749808" y="1755648"/>
+            <a:ext cx="5084064" cy="3575304"/>
           </a:xfrm>
           <a:prstGeom prst="rect">
             <a:avLst/>
@@ -9360,12 +10216,15 @@
           <a:noFill/>
         </p:spPr>
         <p:txBody>
-          <a:bodyPr wrap="square">
+          <a:bodyPr wrap="square" tIns="73152" bIns="73152">
             <a:spAutoFit/>
           </a:bodyPr>
           <a:lstStyle/>
           <a:p>
             <a:pPr>
+              <a:spcAft>
+                <a:spcPts val="800"/>
+              </a:spcAft>
               <a:defRPr sz="1100" b="1">
                 <a:solidFill>
                   <a:srgbClr val="FF3F6C"/>
@@ -9378,6 +10237,15 @@
           </a:p>
           <a:p>
             <a:pPr>
+              <a:lnSpc>
+                <a:spcPct val="118000"/>
+              </a:lnSpc>
+              <a:spcBef>
+                <a:spcPts val="300"/>
+              </a:spcBef>
+              <a:spcAft>
+                <a:spcPts val="600"/>
+              </a:spcAft>
               <a:defRPr sz="950"/>
             </a:pPr>
             <a:r>
@@ -9399,6 +10267,15 @@
           </a:p>
           <a:p>
             <a:pPr>
+              <a:lnSpc>
+                <a:spcPct val="118000"/>
+              </a:lnSpc>
+              <a:spcBef>
+                <a:spcPts val="300"/>
+              </a:spcBef>
+              <a:spcAft>
+                <a:spcPts val="600"/>
+              </a:spcAft>
               <a:defRPr sz="950"/>
             </a:pPr>
             <a:r>
@@ -9420,6 +10297,15 @@
           </a:p>
           <a:p>
             <a:pPr>
+              <a:lnSpc>
+                <a:spcPct val="118000"/>
+              </a:lnSpc>
+              <a:spcBef>
+                <a:spcPts val="300"/>
+              </a:spcBef>
+              <a:spcAft>
+                <a:spcPts val="600"/>
+              </a:spcAft>
               <a:defRPr sz="950"/>
             </a:pPr>
             <a:r>
@@ -9441,6 +10327,15 @@
           </a:p>
           <a:p>
             <a:pPr>
+              <a:lnSpc>
+                <a:spcPct val="118000"/>
+              </a:lnSpc>
+              <a:spcBef>
+                <a:spcPts val="300"/>
+              </a:spcBef>
+              <a:spcAft>
+                <a:spcPts val="600"/>
+              </a:spcAft>
               <a:defRPr sz="950"/>
             </a:pPr>
             <a:r>
@@ -9462,6 +10357,15 @@
           </a:p>
           <a:p>
             <a:pPr>
+              <a:lnSpc>
+                <a:spcPct val="118000"/>
+              </a:lnSpc>
+              <a:spcBef>
+                <a:spcPts val="300"/>
+              </a:spcBef>
+              <a:spcAft>
+                <a:spcPts val="600"/>
+              </a:spcAft>
               <a:defRPr sz="950"/>
             </a:pPr>
             <a:r>
@@ -9483,6 +10387,15 @@
           </a:p>
           <a:p>
             <a:pPr>
+              <a:lnSpc>
+                <a:spcPct val="118000"/>
+              </a:lnSpc>
+              <a:spcBef>
+                <a:spcPts val="300"/>
+              </a:spcBef>
+              <a:spcAft>
+                <a:spcPts val="600"/>
+              </a:spcAft>
               <a:defRPr sz="950"/>
             </a:pPr>
             <a:r>
@@ -9557,8 +10470,8 @@
         </p:nvSpPr>
         <p:spPr>
           <a:xfrm>
-            <a:off x="6355080" y="1783080"/>
-            <a:ext cx="5029200" cy="3520440"/>
+            <a:off x="6327648" y="1755648"/>
+            <a:ext cx="5084064" cy="3575304"/>
           </a:xfrm>
           <a:prstGeom prst="rect">
             <a:avLst/>
@@ -9566,12 +10479,15 @@
           <a:noFill/>
         </p:spPr>
         <p:txBody>
-          <a:bodyPr wrap="square">
+          <a:bodyPr wrap="square" tIns="73152" bIns="73152">
             <a:spAutoFit/>
           </a:bodyPr>
           <a:lstStyle/>
           <a:p>
             <a:pPr>
+              <a:spcAft>
+                <a:spcPts val="800"/>
+              </a:spcAft>
               <a:defRPr sz="1100" b="1">
                 <a:solidFill>
                   <a:srgbClr val="FF3F6C"/>
@@ -9584,6 +10500,12 @@
           </a:p>
           <a:p>
             <a:pPr>
+              <a:spcBef>
+                <a:spcPts val="400"/>
+              </a:spcBef>
+              <a:spcAft>
+                <a:spcPts val="100"/>
+              </a:spcAft>
               <a:defRPr sz="1000"/>
             </a:pPr>
             <a:r>
@@ -9592,9 +10514,22 @@
                   <a:srgbClr val="FF3F6C"/>
                 </a:solidFill>
               </a:rPr>
-              <a:t>► Base Case (100% Target Lift)
-</a:t>
-            </a:r>
+              <a:t>► Base Case (100% Target Lift)</a:t>
+            </a:r>
+          </a:p>
+          <a:p>
+            <a:pPr>
+              <a:lnSpc>
+                <a:spcPct val="115000"/>
+              </a:lnSpc>
+              <a:spcBef>
+                <a:spcPts val="0"/>
+              </a:spcBef>
+              <a:spcAft>
+                <a:spcPts val="600"/>
+              </a:spcAft>
+              <a:defRPr sz="950"/>
+            </a:pPr>
             <a:r>
               <a:rPr>
                 <a:solidFill>
@@ -9606,6 +10541,12 @@
           </a:p>
           <a:p>
             <a:pPr>
+              <a:spcBef>
+                <a:spcPts val="400"/>
+              </a:spcBef>
+              <a:spcAft>
+                <a:spcPts val="100"/>
+              </a:spcAft>
               <a:defRPr sz="1000"/>
             </a:pPr>
             <a:r>
@@ -9614,9 +10555,22 @@
                   <a:srgbClr val="FF3F6C"/>
                 </a:solidFill>
               </a:rPr>
-              <a:t>► Conservative Case (75% Lift)
-</a:t>
-            </a:r>
+              <a:t>► Conservative Case (75% Lift)</a:t>
+            </a:r>
+          </a:p>
+          <a:p>
+            <a:pPr>
+              <a:lnSpc>
+                <a:spcPct val="115000"/>
+              </a:lnSpc>
+              <a:spcBef>
+                <a:spcPts val="0"/>
+              </a:spcBef>
+              <a:spcAft>
+                <a:spcPts val="600"/>
+              </a:spcAft>
+              <a:defRPr sz="950"/>
+            </a:pPr>
             <a:r>
               <a:rPr>
                 <a:solidFill>
@@ -9628,6 +10582,12 @@
           </a:p>
           <a:p>
             <a:pPr>
+              <a:spcBef>
+                <a:spcPts val="400"/>
+              </a:spcBef>
+              <a:spcAft>
+                <a:spcPts val="100"/>
+              </a:spcAft>
               <a:defRPr sz="1000"/>
             </a:pPr>
             <a:r>
@@ -9636,9 +10596,22 @@
                   <a:srgbClr val="FF3F6C"/>
                 </a:solidFill>
               </a:rPr>
-              <a:t>► Stress-Test Case (50% Lift)
-</a:t>
-            </a:r>
+              <a:t>► Stress-Test Case (50% Lift)</a:t>
+            </a:r>
+          </a:p>
+          <a:p>
+            <a:pPr>
+              <a:lnSpc>
+                <a:spcPct val="115000"/>
+              </a:lnSpc>
+              <a:spcBef>
+                <a:spcPts val="0"/>
+              </a:spcBef>
+              <a:spcAft>
+                <a:spcPts val="600"/>
+              </a:spcAft>
+              <a:defRPr sz="950"/>
+            </a:pPr>
             <a:r>
               <a:rPr>
                 <a:solidFill>
@@ -9703,8 +10676,8 @@
         </p:nvSpPr>
         <p:spPr>
           <a:xfrm>
-            <a:off x="777240" y="5605272"/>
-            <a:ext cx="10637215" cy="493776"/>
+            <a:off x="777240" y="5586984"/>
+            <a:ext cx="10637215" cy="530352"/>
           </a:xfrm>
           <a:prstGeom prst="rect">
             <a:avLst/>
@@ -9712,13 +10685,16 @@
           <a:noFill/>
         </p:spPr>
         <p:txBody>
-          <a:bodyPr wrap="square">
+          <a:bodyPr wrap="square" tIns="36576" bIns="36576">
             <a:spAutoFit/>
           </a:bodyPr>
           <a:lstStyle/>
           <a:p>
             <a:pPr>
-              <a:defRPr sz="1000" b="1">
+              <a:spcAft>
+                <a:spcPts val="200"/>
+              </a:spcAft>
+              <a:defRPr sz="950" b="1">
                 <a:solidFill>
                   <a:srgbClr val="4338CA"/>
                 </a:solidFill>
@@ -9730,7 +10706,13 @@
           </a:p>
           <a:p>
             <a:pPr>
-              <a:defRPr sz="1000" b="1">
+              <a:lnSpc>
+                <a:spcPct val="115000"/>
+              </a:lnSpc>
+              <a:spcBef>
+                <a:spcPts val="0"/>
+              </a:spcBef>
+              <a:defRPr sz="950" b="1">
                 <a:solidFill>
                   <a:srgbClr val="282C3F"/>
                 </a:solidFill>
@@ -9780,10 +10762,16 @@
           </a:fontRef>
         </p:style>
         <p:txBody>
-          <a:bodyPr rtlCol="0" anchor="ctr"/>
+          <a:bodyPr rtlCol="0" anchor="ctr" lIns="18288" rIns="18288" tIns="18288" bIns="18288"/>
           <a:lstStyle/>
           <a:p>
             <a:pPr algn="ctr">
+              <a:spcBef>
+                <a:spcPts val="0"/>
+              </a:spcBef>
+              <a:spcAft>
+                <a:spcPts val="0"/>
+              </a:spcAft>
               <a:defRPr sz="900" b="1">
                 <a:solidFill>
                   <a:srgbClr val="535766"/>
@@ -9834,10 +10822,16 @@
           </a:fontRef>
         </p:style>
         <p:txBody>
-          <a:bodyPr rtlCol="0" anchor="ctr"/>
+          <a:bodyPr rtlCol="0" anchor="ctr" lIns="18288" rIns="18288" tIns="18288" bIns="18288"/>
           <a:lstStyle/>
           <a:p>
             <a:pPr algn="ctr">
+              <a:spcBef>
+                <a:spcPts val="0"/>
+              </a:spcBef>
+              <a:spcAft>
+                <a:spcPts val="0"/>
+              </a:spcAft>
               <a:defRPr sz="900" b="1">
                 <a:solidFill>
                   <a:srgbClr val="535766"/>
@@ -9888,10 +10882,16 @@
           </a:fontRef>
         </p:style>
         <p:txBody>
-          <a:bodyPr rtlCol="0" anchor="ctr"/>
+          <a:bodyPr rtlCol="0" anchor="ctr" lIns="18288" rIns="18288" tIns="18288" bIns="18288"/>
           <a:lstStyle/>
           <a:p>
             <a:pPr algn="ctr">
+              <a:spcBef>
+                <a:spcPts val="0"/>
+              </a:spcBef>
+              <a:spcAft>
+                <a:spcPts val="0"/>
+              </a:spcAft>
               <a:defRPr sz="900" b="1">
                 <a:solidFill>
                   <a:srgbClr val="535766"/>
@@ -9942,10 +10942,16 @@
           </a:fontRef>
         </p:style>
         <p:txBody>
-          <a:bodyPr rtlCol="0" anchor="ctr"/>
+          <a:bodyPr rtlCol="0" anchor="ctr" lIns="18288" rIns="18288" tIns="18288" bIns="18288"/>
           <a:lstStyle/>
           <a:p>
             <a:pPr algn="ctr">
+              <a:spcBef>
+                <a:spcPts val="0"/>
+              </a:spcBef>
+              <a:spcAft>
+                <a:spcPts val="0"/>
+              </a:spcAft>
               <a:defRPr sz="900" b="1">
                 <a:solidFill>
                   <a:srgbClr val="535766"/>
@@ -9996,10 +11002,16 @@
           </a:fontRef>
         </p:style>
         <p:txBody>
-          <a:bodyPr rtlCol="0" anchor="ctr"/>
+          <a:bodyPr rtlCol="0" anchor="ctr" lIns="18288" rIns="18288" tIns="18288" bIns="18288"/>
           <a:lstStyle/>
           <a:p>
             <a:pPr algn="ctr">
+              <a:spcBef>
+                <a:spcPts val="0"/>
+              </a:spcBef>
+              <a:spcAft>
+                <a:spcPts val="0"/>
+              </a:spcAft>
               <a:defRPr sz="900" b="1">
                 <a:solidFill>
                   <a:srgbClr val="FFFFFF"/>
@@ -10050,10 +11062,16 @@
           </a:fontRef>
         </p:style>
         <p:txBody>
-          <a:bodyPr rtlCol="0" anchor="ctr"/>
+          <a:bodyPr rtlCol="0" anchor="ctr" lIns="18288" rIns="18288" tIns="18288" bIns="18288"/>
           <a:lstStyle/>
           <a:p>
             <a:pPr algn="ctr">
+              <a:spcBef>
+                <a:spcPts val="0"/>
+              </a:spcBef>
+              <a:spcAft>
+                <a:spcPts val="0"/>
+              </a:spcAft>
               <a:defRPr sz="900" b="1">
                 <a:solidFill>
                   <a:srgbClr val="535766"/>
@@ -10104,10 +11122,16 @@
           </a:fontRef>
         </p:style>
         <p:txBody>
-          <a:bodyPr rtlCol="0" anchor="ctr"/>
+          <a:bodyPr rtlCol="0" anchor="ctr" lIns="18288" rIns="18288" tIns="18288" bIns="18288"/>
           <a:lstStyle/>
           <a:p>
             <a:pPr algn="ctr">
+              <a:spcBef>
+                <a:spcPts val="0"/>
+              </a:spcBef>
+              <a:spcAft>
+                <a:spcPts val="0"/>
+              </a:spcAft>
               <a:defRPr sz="900" b="1">
                 <a:solidFill>
                   <a:srgbClr val="535766"/>
@@ -10158,10 +11182,16 @@
           </a:fontRef>
         </p:style>
         <p:txBody>
-          <a:bodyPr rtlCol="0" anchor="ctr"/>
+          <a:bodyPr rtlCol="0" anchor="ctr" lIns="18288" rIns="18288" tIns="18288" bIns="18288"/>
           <a:lstStyle/>
           <a:p>
             <a:pPr algn="ctr">
+              <a:spcBef>
+                <a:spcPts val="0"/>
+              </a:spcBef>
+              <a:spcAft>
+                <a:spcPts val="0"/>
+              </a:spcAft>
               <a:defRPr sz="900" b="1">
                 <a:solidFill>
                   <a:srgbClr val="535766"/>
@@ -10212,10 +11242,16 @@
           </a:fontRef>
         </p:style>
         <p:txBody>
-          <a:bodyPr rtlCol="0" anchor="ctr"/>
+          <a:bodyPr rtlCol="0" anchor="ctr" lIns="18288" rIns="18288" tIns="18288" bIns="18288"/>
           <a:lstStyle/>
           <a:p>
             <a:pPr algn="ctr">
+              <a:spcBef>
+                <a:spcPts val="0"/>
+              </a:spcBef>
+              <a:spcAft>
+                <a:spcPts val="0"/>
+              </a:spcAft>
               <a:defRPr sz="900" b="1">
                 <a:solidFill>
                   <a:srgbClr val="535766"/>
@@ -10266,10 +11302,16 @@
           </a:fontRef>
         </p:style>
         <p:txBody>
-          <a:bodyPr rtlCol="0" anchor="ctr"/>
+          <a:bodyPr rtlCol="0" anchor="ctr" lIns="18288" rIns="18288" tIns="18288" bIns="18288"/>
           <a:lstStyle/>
           <a:p>
             <a:pPr algn="ctr">
+              <a:spcBef>
+                <a:spcPts val="0"/>
+              </a:spcBef>
+              <a:spcAft>
+                <a:spcPts val="0"/>
+              </a:spcAft>
               <a:defRPr sz="900" b="1">
                 <a:solidFill>
                   <a:srgbClr val="535766"/>
@@ -10336,10 +11378,16 @@
           </a:fontRef>
         </p:style>
         <p:txBody>
-          <a:bodyPr rtlCol="0" anchor="ctr" wrap="square"/>
+          <a:bodyPr rtlCol="0" anchor="ctr" wrap="square" tIns="18288" bIns="18288"/>
           <a:lstStyle/>
           <a:p>
             <a:pPr algn="ctr">
+              <a:spcBef>
+                <a:spcPts val="0"/>
+              </a:spcBef>
+              <a:spcAft>
+                <a:spcPts val="0"/>
+              </a:spcAft>
               <a:defRPr sz="1000" b="1">
                 <a:solidFill>
                   <a:srgbClr val="FFFFFF"/>
@@ -10369,13 +11417,16 @@
           <a:noFill/>
         </p:spPr>
         <p:txBody>
-          <a:bodyPr wrap="square">
+          <a:bodyPr wrap="square" lIns="0" rIns="0" tIns="0" bIns="0">
             <a:spAutoFit/>
           </a:bodyPr>
           <a:lstStyle/>
           <a:p>
             <a:pPr>
-              <a:defRPr sz="1450" b="1">
+              <a:spcAft>
+                <a:spcPts val="300"/>
+              </a:spcAft>
+              <a:defRPr sz="1400" b="1">
                 <a:solidFill>
                   <a:srgbClr val="282C3F"/>
                 </a:solidFill>
@@ -10387,7 +11438,13 @@
           </a:p>
           <a:p>
             <a:pPr>
-              <a:defRPr sz="1150" b="1">
+              <a:spcBef>
+                <a:spcPts val="200"/>
+              </a:spcBef>
+              <a:spcAft>
+                <a:spcPts val="400"/>
+              </a:spcAft>
+              <a:defRPr sz="1050" b="1">
                 <a:solidFill>
                   <a:srgbClr val="FF3F6C"/>
                 </a:solidFill>
@@ -10416,7 +11473,7 @@
           <a:noFill/>
         </p:spPr>
         <p:txBody>
-          <a:bodyPr wrap="none">
+          <a:bodyPr wrap="none" lIns="0" rIns="0" tIns="0" bIns="0">
             <a:spAutoFit/>
           </a:bodyPr>
           <a:lstStyle/>
@@ -10487,8 +11544,8 @@
         </p:nvSpPr>
         <p:spPr>
           <a:xfrm>
-            <a:off x="777240" y="1783080"/>
-            <a:ext cx="3840480" cy="3520440"/>
+            <a:off x="749808" y="1755648"/>
+            <a:ext cx="3895344" cy="3575304"/>
           </a:xfrm>
           <a:prstGeom prst="rect">
             <a:avLst/>
@@ -10496,12 +11553,15 @@
           <a:noFill/>
         </p:spPr>
         <p:txBody>
-          <a:bodyPr wrap="square">
+          <a:bodyPr wrap="square" tIns="73152" bIns="73152">
             <a:spAutoFit/>
           </a:bodyPr>
           <a:lstStyle/>
           <a:p>
             <a:pPr>
+              <a:spcAft>
+                <a:spcPts val="800"/>
+              </a:spcAft>
               <a:defRPr sz="1100" b="1">
                 <a:solidFill>
                   <a:srgbClr val="FF3F6C"/>
@@ -10514,7 +11574,16 @@
           </a:p>
           <a:p>
             <a:pPr>
-              <a:defRPr sz="1000"/>
+              <a:lnSpc>
+                <a:spcPct val="118000"/>
+              </a:lnSpc>
+              <a:spcBef>
+                <a:spcPts val="200"/>
+              </a:spcBef>
+              <a:spcAft>
+                <a:spcPts val="500"/>
+              </a:spcAft>
+              <a:defRPr sz="950"/>
             </a:pPr>
             <a:r>
               <a:rPr b="1">
@@ -10543,7 +11612,16 @@
           </a:p>
           <a:p>
             <a:pPr>
-              <a:defRPr sz="1000"/>
+              <a:lnSpc>
+                <a:spcPct val="118000"/>
+              </a:lnSpc>
+              <a:spcBef>
+                <a:spcPts val="200"/>
+              </a:spcBef>
+              <a:spcAft>
+                <a:spcPts val="500"/>
+              </a:spcAft>
+              <a:defRPr sz="950"/>
             </a:pPr>
             <a:r>
               <a:rPr b="1">
@@ -10572,7 +11650,16 @@
           </a:p>
           <a:p>
             <a:pPr>
-              <a:defRPr sz="1000"/>
+              <a:lnSpc>
+                <a:spcPct val="118000"/>
+              </a:lnSpc>
+              <a:spcBef>
+                <a:spcPts val="200"/>
+              </a:spcBef>
+              <a:spcAft>
+                <a:spcPts val="500"/>
+              </a:spcAft>
+              <a:defRPr sz="950"/>
             </a:pPr>
             <a:r>
               <a:rPr b="1">
@@ -10601,7 +11688,16 @@
           </a:p>
           <a:p>
             <a:pPr>
-              <a:defRPr sz="1000"/>
+              <a:lnSpc>
+                <a:spcPct val="118000"/>
+              </a:lnSpc>
+              <a:spcBef>
+                <a:spcPts val="200"/>
+              </a:spcBef>
+              <a:spcAft>
+                <a:spcPts val="500"/>
+              </a:spcAft>
+              <a:defRPr sz="950"/>
             </a:pPr>
             <a:r>
               <a:rPr b="1">
@@ -10683,8 +11779,8 @@
         </p:nvSpPr>
         <p:spPr>
           <a:xfrm>
-            <a:off x="5029200" y="1783080"/>
-            <a:ext cx="3840480" cy="3520440"/>
+            <a:off x="5001768" y="1755648"/>
+            <a:ext cx="3895344" cy="3575304"/>
           </a:xfrm>
           <a:prstGeom prst="rect">
             <a:avLst/>
@@ -10692,12 +11788,15 @@
           <a:noFill/>
         </p:spPr>
         <p:txBody>
-          <a:bodyPr wrap="square">
+          <a:bodyPr wrap="square" tIns="73152" bIns="73152">
             <a:spAutoFit/>
           </a:bodyPr>
           <a:lstStyle/>
           <a:p>
             <a:pPr>
+              <a:spcAft>
+                <a:spcPts val="800"/>
+              </a:spcAft>
               <a:defRPr sz="1100" b="1">
                 <a:solidFill>
                   <a:srgbClr val="FF3F6C"/>
@@ -10710,7 +11809,16 @@
           </a:p>
           <a:p>
             <a:pPr>
-              <a:defRPr sz="1000"/>
+              <a:lnSpc>
+                <a:spcPct val="118000"/>
+              </a:lnSpc>
+              <a:spcBef>
+                <a:spcPts val="200"/>
+              </a:spcBef>
+              <a:spcAft>
+                <a:spcPts val="500"/>
+              </a:spcAft>
+              <a:defRPr sz="950"/>
             </a:pPr>
             <a:r>
               <a:rPr b="1">
@@ -10739,7 +11847,16 @@
           </a:p>
           <a:p>
             <a:pPr>
-              <a:defRPr sz="1000"/>
+              <a:lnSpc>
+                <a:spcPct val="118000"/>
+              </a:lnSpc>
+              <a:spcBef>
+                <a:spcPts val="200"/>
+              </a:spcBef>
+              <a:spcAft>
+                <a:spcPts val="500"/>
+              </a:spcAft>
+              <a:defRPr sz="950"/>
             </a:pPr>
             <a:r>
               <a:rPr b="1">
@@ -10768,7 +11885,16 @@
           </a:p>
           <a:p>
             <a:pPr>
-              <a:defRPr sz="1000"/>
+              <a:lnSpc>
+                <a:spcPct val="118000"/>
+              </a:lnSpc>
+              <a:spcBef>
+                <a:spcPts val="200"/>
+              </a:spcBef>
+              <a:spcAft>
+                <a:spcPts val="500"/>
+              </a:spcAft>
+              <a:defRPr sz="950"/>
             </a:pPr>
             <a:r>
               <a:rPr b="1">
@@ -10919,8 +12045,8 @@
         </p:nvSpPr>
         <p:spPr>
           <a:xfrm>
-            <a:off x="777240" y="5605272"/>
-            <a:ext cx="10637215" cy="493776"/>
+            <a:off x="777240" y="5586984"/>
+            <a:ext cx="10637215" cy="530352"/>
           </a:xfrm>
           <a:prstGeom prst="rect">
             <a:avLst/>
@@ -10928,13 +12054,16 @@
           <a:noFill/>
         </p:spPr>
         <p:txBody>
-          <a:bodyPr wrap="square">
+          <a:bodyPr wrap="square" tIns="36576" bIns="36576">
             <a:spAutoFit/>
           </a:bodyPr>
           <a:lstStyle/>
           <a:p>
             <a:pPr>
-              <a:defRPr sz="1000" b="1">
+              <a:spcAft>
+                <a:spcPts val="200"/>
+              </a:spcAft>
+              <a:defRPr sz="950" b="1">
                 <a:solidFill>
                   <a:srgbClr val="4338CA"/>
                 </a:solidFill>
@@ -10946,7 +12075,13 @@
           </a:p>
           <a:p>
             <a:pPr>
-              <a:defRPr sz="1000" b="1">
+              <a:lnSpc>
+                <a:spcPct val="115000"/>
+              </a:lnSpc>
+              <a:spcBef>
+                <a:spcPts val="0"/>
+              </a:spcBef>
+              <a:defRPr sz="950" b="1">
                 <a:solidFill>
                   <a:srgbClr val="282C3F"/>
                 </a:solidFill>
@@ -10996,10 +12131,16 @@
           </a:fontRef>
         </p:style>
         <p:txBody>
-          <a:bodyPr rtlCol="0" anchor="ctr"/>
+          <a:bodyPr rtlCol="0" anchor="ctr" lIns="18288" rIns="18288" tIns="18288" bIns="18288"/>
           <a:lstStyle/>
           <a:p>
             <a:pPr algn="ctr">
+              <a:spcBef>
+                <a:spcPts val="0"/>
+              </a:spcBef>
+              <a:spcAft>
+                <a:spcPts val="0"/>
+              </a:spcAft>
               <a:defRPr sz="900" b="1">
                 <a:solidFill>
                   <a:srgbClr val="535766"/>
@@ -11050,10 +12191,16 @@
           </a:fontRef>
         </p:style>
         <p:txBody>
-          <a:bodyPr rtlCol="0" anchor="ctr"/>
+          <a:bodyPr rtlCol="0" anchor="ctr" lIns="18288" rIns="18288" tIns="18288" bIns="18288"/>
           <a:lstStyle/>
           <a:p>
             <a:pPr algn="ctr">
+              <a:spcBef>
+                <a:spcPts val="0"/>
+              </a:spcBef>
+              <a:spcAft>
+                <a:spcPts val="0"/>
+              </a:spcAft>
               <a:defRPr sz="900" b="1">
                 <a:solidFill>
                   <a:srgbClr val="535766"/>
@@ -11104,10 +12251,16 @@
           </a:fontRef>
         </p:style>
         <p:txBody>
-          <a:bodyPr rtlCol="0" anchor="ctr"/>
+          <a:bodyPr rtlCol="0" anchor="ctr" lIns="18288" rIns="18288" tIns="18288" bIns="18288"/>
           <a:lstStyle/>
           <a:p>
             <a:pPr algn="ctr">
+              <a:spcBef>
+                <a:spcPts val="0"/>
+              </a:spcBef>
+              <a:spcAft>
+                <a:spcPts val="0"/>
+              </a:spcAft>
               <a:defRPr sz="900" b="1">
                 <a:solidFill>
                   <a:srgbClr val="535766"/>
@@ -11158,10 +12311,16 @@
           </a:fontRef>
         </p:style>
         <p:txBody>
-          <a:bodyPr rtlCol="0" anchor="ctr"/>
+          <a:bodyPr rtlCol="0" anchor="ctr" lIns="18288" rIns="18288" tIns="18288" bIns="18288"/>
           <a:lstStyle/>
           <a:p>
             <a:pPr algn="ctr">
+              <a:spcBef>
+                <a:spcPts val="0"/>
+              </a:spcBef>
+              <a:spcAft>
+                <a:spcPts val="0"/>
+              </a:spcAft>
               <a:defRPr sz="900" b="1">
                 <a:solidFill>
                   <a:srgbClr val="535766"/>
@@ -11212,10 +12371,16 @@
           </a:fontRef>
         </p:style>
         <p:txBody>
-          <a:bodyPr rtlCol="0" anchor="ctr"/>
+          <a:bodyPr rtlCol="0" anchor="ctr" lIns="18288" rIns="18288" tIns="18288" bIns="18288"/>
           <a:lstStyle/>
           <a:p>
             <a:pPr algn="ctr">
+              <a:spcBef>
+                <a:spcPts val="0"/>
+              </a:spcBef>
+              <a:spcAft>
+                <a:spcPts val="0"/>
+              </a:spcAft>
               <a:defRPr sz="900" b="1">
                 <a:solidFill>
                   <a:srgbClr val="535766"/>
@@ -11266,10 +12431,16 @@
           </a:fontRef>
         </p:style>
         <p:txBody>
-          <a:bodyPr rtlCol="0" anchor="ctr"/>
+          <a:bodyPr rtlCol="0" anchor="ctr" lIns="18288" rIns="18288" tIns="18288" bIns="18288"/>
           <a:lstStyle/>
           <a:p>
             <a:pPr algn="ctr">
+              <a:spcBef>
+                <a:spcPts val="0"/>
+              </a:spcBef>
+              <a:spcAft>
+                <a:spcPts val="0"/>
+              </a:spcAft>
               <a:defRPr sz="900" b="1">
                 <a:solidFill>
                   <a:srgbClr val="FFFFFF"/>
@@ -11320,10 +12491,16 @@
           </a:fontRef>
         </p:style>
         <p:txBody>
-          <a:bodyPr rtlCol="0" anchor="ctr"/>
+          <a:bodyPr rtlCol="0" anchor="ctr" lIns="18288" rIns="18288" tIns="18288" bIns="18288"/>
           <a:lstStyle/>
           <a:p>
             <a:pPr algn="ctr">
+              <a:spcBef>
+                <a:spcPts val="0"/>
+              </a:spcBef>
+              <a:spcAft>
+                <a:spcPts val="0"/>
+              </a:spcAft>
               <a:defRPr sz="900" b="1">
                 <a:solidFill>
                   <a:srgbClr val="535766"/>
@@ -11374,10 +12551,16 @@
           </a:fontRef>
         </p:style>
         <p:txBody>
-          <a:bodyPr rtlCol="0" anchor="ctr"/>
+          <a:bodyPr rtlCol="0" anchor="ctr" lIns="18288" rIns="18288" tIns="18288" bIns="18288"/>
           <a:lstStyle/>
           <a:p>
             <a:pPr algn="ctr">
+              <a:spcBef>
+                <a:spcPts val="0"/>
+              </a:spcBef>
+              <a:spcAft>
+                <a:spcPts val="0"/>
+              </a:spcAft>
               <a:defRPr sz="900" b="1">
                 <a:solidFill>
                   <a:srgbClr val="535766"/>
@@ -11428,10 +12611,16 @@
           </a:fontRef>
         </p:style>
         <p:txBody>
-          <a:bodyPr rtlCol="0" anchor="ctr"/>
+          <a:bodyPr rtlCol="0" anchor="ctr" lIns="18288" rIns="18288" tIns="18288" bIns="18288"/>
           <a:lstStyle/>
           <a:p>
             <a:pPr algn="ctr">
+              <a:spcBef>
+                <a:spcPts val="0"/>
+              </a:spcBef>
+              <a:spcAft>
+                <a:spcPts val="0"/>
+              </a:spcAft>
               <a:defRPr sz="900" b="1">
                 <a:solidFill>
                   <a:srgbClr val="535766"/>
@@ -11482,10 +12671,16 @@
           </a:fontRef>
         </p:style>
         <p:txBody>
-          <a:bodyPr rtlCol="0" anchor="ctr"/>
+          <a:bodyPr rtlCol="0" anchor="ctr" lIns="18288" rIns="18288" tIns="18288" bIns="18288"/>
           <a:lstStyle/>
           <a:p>
             <a:pPr algn="ctr">
+              <a:spcBef>
+                <a:spcPts val="0"/>
+              </a:spcBef>
+              <a:spcAft>
+                <a:spcPts val="0"/>
+              </a:spcAft>
               <a:defRPr sz="900" b="1">
                 <a:solidFill>
                   <a:srgbClr val="535766"/>
@@ -11552,10 +12747,16 @@
           </a:fontRef>
         </p:style>
         <p:txBody>
-          <a:bodyPr rtlCol="0" anchor="ctr" wrap="square"/>
+          <a:bodyPr rtlCol="0" anchor="ctr" wrap="square" tIns="18288" bIns="18288"/>
           <a:lstStyle/>
           <a:p>
             <a:pPr algn="ctr">
+              <a:spcBef>
+                <a:spcPts val="0"/>
+              </a:spcBef>
+              <a:spcAft>
+                <a:spcPts val="0"/>
+              </a:spcAft>
               <a:defRPr sz="1000" b="1">
                 <a:solidFill>
                   <a:srgbClr val="FFFFFF"/>
@@ -11585,13 +12786,16 @@
           <a:noFill/>
         </p:spPr>
         <p:txBody>
-          <a:bodyPr wrap="square">
+          <a:bodyPr wrap="square" lIns="0" rIns="0" tIns="0" bIns="0">
             <a:spAutoFit/>
           </a:bodyPr>
           <a:lstStyle/>
           <a:p>
             <a:pPr>
-              <a:defRPr sz="1450" b="1">
+              <a:spcAft>
+                <a:spcPts val="300"/>
+              </a:spcAft>
+              <a:defRPr sz="1400" b="1">
                 <a:solidFill>
                   <a:srgbClr val="282C3F"/>
                 </a:solidFill>
@@ -11603,7 +12807,13 @@
           </a:p>
           <a:p>
             <a:pPr>
-              <a:defRPr sz="1150" b="1">
+              <a:spcBef>
+                <a:spcPts val="200"/>
+              </a:spcBef>
+              <a:spcAft>
+                <a:spcPts val="400"/>
+              </a:spcAft>
+              <a:defRPr sz="1050" b="1">
                 <a:solidFill>
                   <a:srgbClr val="FF3F6C"/>
                 </a:solidFill>
@@ -11632,7 +12842,7 @@
           <a:noFill/>
         </p:spPr>
         <p:txBody>
-          <a:bodyPr wrap="none">
+          <a:bodyPr wrap="none" lIns="0" rIns="0" tIns="0" bIns="0">
             <a:spAutoFit/>
           </a:bodyPr>
           <a:lstStyle/>
@@ -11712,12 +12922,15 @@
           <a:noFill/>
         </p:spPr>
         <p:txBody>
-          <a:bodyPr wrap="square">
+          <a:bodyPr wrap="square" lIns="45720" rIns="45720" tIns="36576" bIns="36576">
             <a:spAutoFit/>
           </a:bodyPr>
           <a:lstStyle/>
           <a:p>
             <a:pPr>
+              <a:spcAft>
+                <a:spcPts val="400"/>
+              </a:spcAft>
               <a:defRPr sz="950" b="1">
                 <a:solidFill>
                   <a:srgbClr val="FF3F6C"/>
@@ -11771,12 +12984,15 @@
           <a:noFill/>
         </p:spPr>
         <p:txBody>
-          <a:bodyPr wrap="square">
+          <a:bodyPr wrap="square" lIns="45720" rIns="45720" tIns="18288" bIns="18288">
             <a:spAutoFit/>
           </a:bodyPr>
           <a:lstStyle/>
           <a:p>
             <a:pPr>
+              <a:spcBef>
+                <a:spcPts val="200"/>
+              </a:spcBef>
               <a:defRPr sz="850" b="1">
                 <a:solidFill>
                   <a:srgbClr val="FF3F6C"/>
@@ -11851,12 +13067,15 @@
           <a:noFill/>
         </p:spPr>
         <p:txBody>
-          <a:bodyPr wrap="square">
+          <a:bodyPr wrap="square" lIns="45720" rIns="45720" tIns="36576" bIns="36576">
             <a:spAutoFit/>
           </a:bodyPr>
           <a:lstStyle/>
           <a:p>
             <a:pPr>
+              <a:spcAft>
+                <a:spcPts val="400"/>
+              </a:spcAft>
               <a:defRPr sz="950" b="1">
                 <a:solidFill>
                   <a:srgbClr val="FF3F6C"/>
@@ -11910,12 +13129,15 @@
           <a:noFill/>
         </p:spPr>
         <p:txBody>
-          <a:bodyPr wrap="square">
+          <a:bodyPr wrap="square" lIns="45720" rIns="45720" tIns="18288" bIns="18288">
             <a:spAutoFit/>
           </a:bodyPr>
           <a:lstStyle/>
           <a:p>
             <a:pPr>
+              <a:spcBef>
+                <a:spcPts val="200"/>
+              </a:spcBef>
               <a:defRPr sz="850" b="1">
                 <a:solidFill>
                   <a:srgbClr val="FF3F6C"/>
@@ -11990,12 +13212,15 @@
           <a:noFill/>
         </p:spPr>
         <p:txBody>
-          <a:bodyPr wrap="square">
+          <a:bodyPr wrap="square" lIns="45720" rIns="45720" tIns="36576" bIns="36576">
             <a:spAutoFit/>
           </a:bodyPr>
           <a:lstStyle/>
           <a:p>
             <a:pPr>
+              <a:spcAft>
+                <a:spcPts val="400"/>
+              </a:spcAft>
               <a:defRPr sz="950" b="1">
                 <a:solidFill>
                   <a:srgbClr val="FF3F6C"/>
@@ -12049,12 +13274,15 @@
           <a:noFill/>
         </p:spPr>
         <p:txBody>
-          <a:bodyPr wrap="square">
+          <a:bodyPr wrap="square" lIns="45720" rIns="45720" tIns="18288" bIns="18288">
             <a:spAutoFit/>
           </a:bodyPr>
           <a:lstStyle/>
           <a:p>
             <a:pPr>
+              <a:spcBef>
+                <a:spcPts val="200"/>
+              </a:spcBef>
               <a:defRPr sz="850" b="1">
                 <a:solidFill>
                   <a:srgbClr val="FF3F6C"/>
@@ -12120,8 +13348,8 @@
         </p:nvSpPr>
         <p:spPr>
           <a:xfrm>
-            <a:off x="777240" y="5605272"/>
-            <a:ext cx="10637215" cy="493776"/>
+            <a:off x="777240" y="5586984"/>
+            <a:ext cx="10637215" cy="530352"/>
           </a:xfrm>
           <a:prstGeom prst="rect">
             <a:avLst/>
@@ -12129,13 +13357,16 @@
           <a:noFill/>
         </p:spPr>
         <p:txBody>
-          <a:bodyPr wrap="square">
+          <a:bodyPr wrap="square" tIns="36576" bIns="36576">
             <a:spAutoFit/>
           </a:bodyPr>
           <a:lstStyle/>
           <a:p>
             <a:pPr>
-              <a:defRPr sz="1000" b="1">
+              <a:spcAft>
+                <a:spcPts val="200"/>
+              </a:spcAft>
+              <a:defRPr sz="950" b="1">
                 <a:solidFill>
                   <a:srgbClr val="4338CA"/>
                 </a:solidFill>
@@ -12147,7 +13378,13 @@
           </a:p>
           <a:p>
             <a:pPr>
-              <a:defRPr sz="1000" b="1">
+              <a:lnSpc>
+                <a:spcPct val="115000"/>
+              </a:lnSpc>
+              <a:spcBef>
+                <a:spcPts val="0"/>
+              </a:spcBef>
+              <a:defRPr sz="950" b="1">
                 <a:solidFill>
                   <a:srgbClr val="282C3F"/>
                 </a:solidFill>
@@ -12197,10 +13434,16 @@
           </a:fontRef>
         </p:style>
         <p:txBody>
-          <a:bodyPr rtlCol="0" anchor="ctr"/>
+          <a:bodyPr rtlCol="0" anchor="ctr" lIns="18288" rIns="18288" tIns="18288" bIns="18288"/>
           <a:lstStyle/>
           <a:p>
             <a:pPr algn="ctr">
+              <a:spcBef>
+                <a:spcPts val="0"/>
+              </a:spcBef>
+              <a:spcAft>
+                <a:spcPts val="0"/>
+              </a:spcAft>
               <a:defRPr sz="900" b="1">
                 <a:solidFill>
                   <a:srgbClr val="535766"/>
@@ -12251,10 +13494,16 @@
           </a:fontRef>
         </p:style>
         <p:txBody>
-          <a:bodyPr rtlCol="0" anchor="ctr"/>
+          <a:bodyPr rtlCol="0" anchor="ctr" lIns="18288" rIns="18288" tIns="18288" bIns="18288"/>
           <a:lstStyle/>
           <a:p>
             <a:pPr algn="ctr">
+              <a:spcBef>
+                <a:spcPts val="0"/>
+              </a:spcBef>
+              <a:spcAft>
+                <a:spcPts val="0"/>
+              </a:spcAft>
               <a:defRPr sz="900" b="1">
                 <a:solidFill>
                   <a:srgbClr val="535766"/>
@@ -12305,10 +13554,16 @@
           </a:fontRef>
         </p:style>
         <p:txBody>
-          <a:bodyPr rtlCol="0" anchor="ctr"/>
+          <a:bodyPr rtlCol="0" anchor="ctr" lIns="18288" rIns="18288" tIns="18288" bIns="18288"/>
           <a:lstStyle/>
           <a:p>
             <a:pPr algn="ctr">
+              <a:spcBef>
+                <a:spcPts val="0"/>
+              </a:spcBef>
+              <a:spcAft>
+                <a:spcPts val="0"/>
+              </a:spcAft>
               <a:defRPr sz="900" b="1">
                 <a:solidFill>
                   <a:srgbClr val="535766"/>
@@ -12359,10 +13614,16 @@
           </a:fontRef>
         </p:style>
         <p:txBody>
-          <a:bodyPr rtlCol="0" anchor="ctr"/>
+          <a:bodyPr rtlCol="0" anchor="ctr" lIns="18288" rIns="18288" tIns="18288" bIns="18288"/>
           <a:lstStyle/>
           <a:p>
             <a:pPr algn="ctr">
+              <a:spcBef>
+                <a:spcPts val="0"/>
+              </a:spcBef>
+              <a:spcAft>
+                <a:spcPts val="0"/>
+              </a:spcAft>
               <a:defRPr sz="900" b="1">
                 <a:solidFill>
                   <a:srgbClr val="535766"/>
@@ -12413,10 +13674,16 @@
           </a:fontRef>
         </p:style>
         <p:txBody>
-          <a:bodyPr rtlCol="0" anchor="ctr"/>
+          <a:bodyPr rtlCol="0" anchor="ctr" lIns="18288" rIns="18288" tIns="18288" bIns="18288"/>
           <a:lstStyle/>
           <a:p>
             <a:pPr algn="ctr">
+              <a:spcBef>
+                <a:spcPts val="0"/>
+              </a:spcBef>
+              <a:spcAft>
+                <a:spcPts val="0"/>
+              </a:spcAft>
               <a:defRPr sz="900" b="1">
                 <a:solidFill>
                   <a:srgbClr val="535766"/>
@@ -12467,10 +13734,16 @@
           </a:fontRef>
         </p:style>
         <p:txBody>
-          <a:bodyPr rtlCol="0" anchor="ctr"/>
+          <a:bodyPr rtlCol="0" anchor="ctr" lIns="18288" rIns="18288" tIns="18288" bIns="18288"/>
           <a:lstStyle/>
           <a:p>
             <a:pPr algn="ctr">
+              <a:spcBef>
+                <a:spcPts val="0"/>
+              </a:spcBef>
+              <a:spcAft>
+                <a:spcPts val="0"/>
+              </a:spcAft>
               <a:defRPr sz="900" b="1">
                 <a:solidFill>
                   <a:srgbClr val="535766"/>
@@ -12521,10 +13794,16 @@
           </a:fontRef>
         </p:style>
         <p:txBody>
-          <a:bodyPr rtlCol="0" anchor="ctr"/>
+          <a:bodyPr rtlCol="0" anchor="ctr" lIns="18288" rIns="18288" tIns="18288" bIns="18288"/>
           <a:lstStyle/>
           <a:p>
             <a:pPr algn="ctr">
+              <a:spcBef>
+                <a:spcPts val="0"/>
+              </a:spcBef>
+              <a:spcAft>
+                <a:spcPts val="0"/>
+              </a:spcAft>
               <a:defRPr sz="900" b="1">
                 <a:solidFill>
                   <a:srgbClr val="FFFFFF"/>
@@ -12575,10 +13854,16 @@
           </a:fontRef>
         </p:style>
         <p:txBody>
-          <a:bodyPr rtlCol="0" anchor="ctr"/>
+          <a:bodyPr rtlCol="0" anchor="ctr" lIns="18288" rIns="18288" tIns="18288" bIns="18288"/>
           <a:lstStyle/>
           <a:p>
             <a:pPr algn="ctr">
+              <a:spcBef>
+                <a:spcPts val="0"/>
+              </a:spcBef>
+              <a:spcAft>
+                <a:spcPts val="0"/>
+              </a:spcAft>
               <a:defRPr sz="900" b="1">
                 <a:solidFill>
                   <a:srgbClr val="535766"/>
@@ -12629,10 +13914,16 @@
           </a:fontRef>
         </p:style>
         <p:txBody>
-          <a:bodyPr rtlCol="0" anchor="ctr"/>
+          <a:bodyPr rtlCol="0" anchor="ctr" lIns="18288" rIns="18288" tIns="18288" bIns="18288"/>
           <a:lstStyle/>
           <a:p>
             <a:pPr algn="ctr">
+              <a:spcBef>
+                <a:spcPts val="0"/>
+              </a:spcBef>
+              <a:spcAft>
+                <a:spcPts val="0"/>
+              </a:spcAft>
               <a:defRPr sz="900" b="1">
                 <a:solidFill>
                   <a:srgbClr val="535766"/>
@@ -12683,10 +13974,16 @@
           </a:fontRef>
         </p:style>
         <p:txBody>
-          <a:bodyPr rtlCol="0" anchor="ctr"/>
+          <a:bodyPr rtlCol="0" anchor="ctr" lIns="18288" rIns="18288" tIns="18288" bIns="18288"/>
           <a:lstStyle/>
           <a:p>
             <a:pPr algn="ctr">
+              <a:spcBef>
+                <a:spcPts val="0"/>
+              </a:spcBef>
+              <a:spcAft>
+                <a:spcPts val="0"/>
+              </a:spcAft>
               <a:defRPr sz="900" b="1">
                 <a:solidFill>
                   <a:srgbClr val="535766"/>
@@ -12753,10 +14050,16 @@
           </a:fontRef>
         </p:style>
         <p:txBody>
-          <a:bodyPr rtlCol="0" anchor="ctr" wrap="square"/>
+          <a:bodyPr rtlCol="0" anchor="ctr" wrap="square" tIns="18288" bIns="18288"/>
           <a:lstStyle/>
           <a:p>
             <a:pPr algn="ctr">
+              <a:spcBef>
+                <a:spcPts val="0"/>
+              </a:spcBef>
+              <a:spcAft>
+                <a:spcPts val="0"/>
+              </a:spcAft>
               <a:defRPr sz="1000" b="1">
                 <a:solidFill>
                   <a:srgbClr val="FFFFFF"/>
@@ -12786,13 +14089,16 @@
           <a:noFill/>
         </p:spPr>
         <p:txBody>
-          <a:bodyPr wrap="square">
+          <a:bodyPr wrap="square" lIns="0" rIns="0" tIns="0" bIns="0">
             <a:spAutoFit/>
           </a:bodyPr>
           <a:lstStyle/>
           <a:p>
             <a:pPr>
-              <a:defRPr sz="1450" b="1">
+              <a:spcAft>
+                <a:spcPts val="300"/>
+              </a:spcAft>
+              <a:defRPr sz="1400" b="1">
                 <a:solidFill>
                   <a:srgbClr val="282C3F"/>
                 </a:solidFill>
@@ -12804,7 +14110,13 @@
           </a:p>
           <a:p>
             <a:pPr>
-              <a:defRPr sz="1150" b="1">
+              <a:spcBef>
+                <a:spcPts val="200"/>
+              </a:spcBef>
+              <a:spcAft>
+                <a:spcPts val="400"/>
+              </a:spcAft>
+              <a:defRPr sz="1050" b="1">
                 <a:solidFill>
                   <a:srgbClr val="FF3F6C"/>
                 </a:solidFill>
@@ -12833,7 +14145,7 @@
           <a:noFill/>
         </p:spPr>
         <p:txBody>
-          <a:bodyPr wrap="none">
+          <a:bodyPr wrap="none" lIns="0" rIns="0" tIns="0" bIns="0">
             <a:spAutoFit/>
           </a:bodyPr>
           <a:lstStyle/>
@@ -12904,8 +14216,8 @@
         </p:nvSpPr>
         <p:spPr>
           <a:xfrm>
-            <a:off x="777240" y="1783080"/>
-            <a:ext cx="3840480" cy="3520440"/>
+            <a:off x="749808" y="1755648"/>
+            <a:ext cx="3895344" cy="3575304"/>
           </a:xfrm>
           <a:prstGeom prst="rect">
             <a:avLst/>
@@ -12913,12 +14225,15 @@
           <a:noFill/>
         </p:spPr>
         <p:txBody>
-          <a:bodyPr wrap="square">
+          <a:bodyPr wrap="square" tIns="73152" bIns="73152">
             <a:spAutoFit/>
           </a:bodyPr>
           <a:lstStyle/>
           <a:p>
             <a:pPr>
+              <a:spcAft>
+                <a:spcPts val="800"/>
+              </a:spcAft>
               <a:defRPr sz="1100" b="1">
                 <a:solidFill>
                   <a:srgbClr val="FF3F6C"/>
@@ -12931,7 +14246,16 @@
           </a:p>
           <a:p>
             <a:pPr>
-              <a:defRPr sz="1000"/>
+              <a:lnSpc>
+                <a:spcPct val="118000"/>
+              </a:lnSpc>
+              <a:spcBef>
+                <a:spcPts val="200"/>
+              </a:spcBef>
+              <a:spcAft>
+                <a:spcPts val="500"/>
+              </a:spcAft>
+              <a:defRPr sz="950"/>
             </a:pPr>
             <a:r>
               <a:rPr b="1">
@@ -12960,7 +14284,16 @@
           </a:p>
           <a:p>
             <a:pPr>
-              <a:defRPr sz="1000"/>
+              <a:lnSpc>
+                <a:spcPct val="118000"/>
+              </a:lnSpc>
+              <a:spcBef>
+                <a:spcPts val="200"/>
+              </a:spcBef>
+              <a:spcAft>
+                <a:spcPts val="500"/>
+              </a:spcAft>
+              <a:defRPr sz="950"/>
             </a:pPr>
             <a:r>
               <a:rPr b="1">
@@ -12989,7 +14322,16 @@
           </a:p>
           <a:p>
             <a:pPr>
-              <a:defRPr sz="1000"/>
+              <a:lnSpc>
+                <a:spcPct val="118000"/>
+              </a:lnSpc>
+              <a:spcBef>
+                <a:spcPts val="200"/>
+              </a:spcBef>
+              <a:spcAft>
+                <a:spcPts val="500"/>
+              </a:spcAft>
+              <a:defRPr sz="950"/>
             </a:pPr>
             <a:r>
               <a:rPr b="1">
@@ -13018,7 +14360,16 @@
           </a:p>
           <a:p>
             <a:pPr>
-              <a:defRPr sz="1000"/>
+              <a:lnSpc>
+                <a:spcPct val="118000"/>
+              </a:lnSpc>
+              <a:spcBef>
+                <a:spcPts val="200"/>
+              </a:spcBef>
+              <a:spcAft>
+                <a:spcPts val="500"/>
+              </a:spcAft>
+              <a:defRPr sz="950"/>
             </a:pPr>
             <a:r>
               <a:rPr b="1">
@@ -13100,8 +14451,8 @@
         </p:nvSpPr>
         <p:spPr>
           <a:xfrm>
-            <a:off x="5029200" y="1783080"/>
-            <a:ext cx="3840480" cy="3520440"/>
+            <a:off x="5001768" y="1755648"/>
+            <a:ext cx="3895344" cy="3575304"/>
           </a:xfrm>
           <a:prstGeom prst="rect">
             <a:avLst/>
@@ -13109,12 +14460,15 @@
           <a:noFill/>
         </p:spPr>
         <p:txBody>
-          <a:bodyPr wrap="square">
+          <a:bodyPr wrap="square" tIns="73152" bIns="73152">
             <a:spAutoFit/>
           </a:bodyPr>
           <a:lstStyle/>
           <a:p>
             <a:pPr>
+              <a:spcAft>
+                <a:spcPts val="800"/>
+              </a:spcAft>
               <a:defRPr sz="1100" b="1">
                 <a:solidFill>
                   <a:srgbClr val="FF3F6C"/>
@@ -13127,7 +14481,16 @@
           </a:p>
           <a:p>
             <a:pPr>
-              <a:defRPr sz="1000"/>
+              <a:lnSpc>
+                <a:spcPct val="118000"/>
+              </a:lnSpc>
+              <a:spcBef>
+                <a:spcPts val="200"/>
+              </a:spcBef>
+              <a:spcAft>
+                <a:spcPts val="500"/>
+              </a:spcAft>
+              <a:defRPr sz="950"/>
             </a:pPr>
             <a:r>
               <a:rPr b="1">
@@ -13156,7 +14519,16 @@
           </a:p>
           <a:p>
             <a:pPr>
-              <a:defRPr sz="1000"/>
+              <a:lnSpc>
+                <a:spcPct val="118000"/>
+              </a:lnSpc>
+              <a:spcBef>
+                <a:spcPts val="200"/>
+              </a:spcBef>
+              <a:spcAft>
+                <a:spcPts val="500"/>
+              </a:spcAft>
+              <a:defRPr sz="950"/>
             </a:pPr>
             <a:r>
               <a:rPr b="1">
@@ -13185,7 +14557,16 @@
           </a:p>
           <a:p>
             <a:pPr>
-              <a:defRPr sz="1000"/>
+              <a:lnSpc>
+                <a:spcPct val="118000"/>
+              </a:lnSpc>
+              <a:spcBef>
+                <a:spcPts val="200"/>
+              </a:spcBef>
+              <a:spcAft>
+                <a:spcPts val="500"/>
+              </a:spcAft>
+              <a:defRPr sz="950"/>
             </a:pPr>
             <a:r>
               <a:rPr b="1">
@@ -13214,7 +14595,16 @@
           </a:p>
           <a:p>
             <a:pPr>
-              <a:defRPr sz="1000"/>
+              <a:lnSpc>
+                <a:spcPct val="118000"/>
+              </a:lnSpc>
+              <a:spcBef>
+                <a:spcPts val="200"/>
+              </a:spcBef>
+              <a:spcAft>
+                <a:spcPts val="500"/>
+              </a:spcAft>
+              <a:defRPr sz="950"/>
             </a:pPr>
             <a:r>
               <a:rPr b="1">
@@ -13365,8 +14755,8 @@
         </p:nvSpPr>
         <p:spPr>
           <a:xfrm>
-            <a:off x="777240" y="5605272"/>
-            <a:ext cx="10637215" cy="493776"/>
+            <a:off x="777240" y="5586984"/>
+            <a:ext cx="10637215" cy="530352"/>
           </a:xfrm>
           <a:prstGeom prst="rect">
             <a:avLst/>
@@ -13374,13 +14764,16 @@
           <a:noFill/>
         </p:spPr>
         <p:txBody>
-          <a:bodyPr wrap="square">
+          <a:bodyPr wrap="square" tIns="36576" bIns="36576">
             <a:spAutoFit/>
           </a:bodyPr>
           <a:lstStyle/>
           <a:p>
             <a:pPr>
-              <a:defRPr sz="1000" b="1">
+              <a:spcAft>
+                <a:spcPts val="200"/>
+              </a:spcAft>
+              <a:defRPr sz="950" b="1">
                 <a:solidFill>
                   <a:srgbClr val="4338CA"/>
                 </a:solidFill>
@@ -13392,7 +14785,13 @@
           </a:p>
           <a:p>
             <a:pPr>
-              <a:defRPr sz="1000" b="1">
+              <a:lnSpc>
+                <a:spcPct val="115000"/>
+              </a:lnSpc>
+              <a:spcBef>
+                <a:spcPts val="0"/>
+              </a:spcBef>
+              <a:defRPr sz="950" b="1">
                 <a:solidFill>
                   <a:srgbClr val="282C3F"/>
                 </a:solidFill>
@@ -13442,10 +14841,16 @@
           </a:fontRef>
         </p:style>
         <p:txBody>
-          <a:bodyPr rtlCol="0" anchor="ctr"/>
+          <a:bodyPr rtlCol="0" anchor="ctr" lIns="18288" rIns="18288" tIns="18288" bIns="18288"/>
           <a:lstStyle/>
           <a:p>
             <a:pPr algn="ctr">
+              <a:spcBef>
+                <a:spcPts val="0"/>
+              </a:spcBef>
+              <a:spcAft>
+                <a:spcPts val="0"/>
+              </a:spcAft>
               <a:defRPr sz="900" b="1">
                 <a:solidFill>
                   <a:srgbClr val="535766"/>
@@ -13496,10 +14901,16 @@
           </a:fontRef>
         </p:style>
         <p:txBody>
-          <a:bodyPr rtlCol="0" anchor="ctr"/>
+          <a:bodyPr rtlCol="0" anchor="ctr" lIns="18288" rIns="18288" tIns="18288" bIns="18288"/>
           <a:lstStyle/>
           <a:p>
             <a:pPr algn="ctr">
+              <a:spcBef>
+                <a:spcPts val="0"/>
+              </a:spcBef>
+              <a:spcAft>
+                <a:spcPts val="0"/>
+              </a:spcAft>
               <a:defRPr sz="900" b="1">
                 <a:solidFill>
                   <a:srgbClr val="535766"/>
@@ -13550,10 +14961,16 @@
           </a:fontRef>
         </p:style>
         <p:txBody>
-          <a:bodyPr rtlCol="0" anchor="ctr"/>
+          <a:bodyPr rtlCol="0" anchor="ctr" lIns="18288" rIns="18288" tIns="18288" bIns="18288"/>
           <a:lstStyle/>
           <a:p>
             <a:pPr algn="ctr">
+              <a:spcBef>
+                <a:spcPts val="0"/>
+              </a:spcBef>
+              <a:spcAft>
+                <a:spcPts val="0"/>
+              </a:spcAft>
               <a:defRPr sz="900" b="1">
                 <a:solidFill>
                   <a:srgbClr val="535766"/>
@@ -13604,10 +15021,16 @@
           </a:fontRef>
         </p:style>
         <p:txBody>
-          <a:bodyPr rtlCol="0" anchor="ctr"/>
+          <a:bodyPr rtlCol="0" anchor="ctr" lIns="18288" rIns="18288" tIns="18288" bIns="18288"/>
           <a:lstStyle/>
           <a:p>
             <a:pPr algn="ctr">
+              <a:spcBef>
+                <a:spcPts val="0"/>
+              </a:spcBef>
+              <a:spcAft>
+                <a:spcPts val="0"/>
+              </a:spcAft>
               <a:defRPr sz="900" b="1">
                 <a:solidFill>
                   <a:srgbClr val="535766"/>
@@ -13658,10 +15081,16 @@
           </a:fontRef>
         </p:style>
         <p:txBody>
-          <a:bodyPr rtlCol="0" anchor="ctr"/>
+          <a:bodyPr rtlCol="0" anchor="ctr" lIns="18288" rIns="18288" tIns="18288" bIns="18288"/>
           <a:lstStyle/>
           <a:p>
             <a:pPr algn="ctr">
+              <a:spcBef>
+                <a:spcPts val="0"/>
+              </a:spcBef>
+              <a:spcAft>
+                <a:spcPts val="0"/>
+              </a:spcAft>
               <a:defRPr sz="900" b="1">
                 <a:solidFill>
                   <a:srgbClr val="535766"/>
@@ -13712,10 +15141,16 @@
           </a:fontRef>
         </p:style>
         <p:txBody>
-          <a:bodyPr rtlCol="0" anchor="ctr"/>
+          <a:bodyPr rtlCol="0" anchor="ctr" lIns="18288" rIns="18288" tIns="18288" bIns="18288"/>
           <a:lstStyle/>
           <a:p>
             <a:pPr algn="ctr">
+              <a:spcBef>
+                <a:spcPts val="0"/>
+              </a:spcBef>
+              <a:spcAft>
+                <a:spcPts val="0"/>
+              </a:spcAft>
               <a:defRPr sz="900" b="1">
                 <a:solidFill>
                   <a:srgbClr val="535766"/>
@@ -13766,10 +15201,16 @@
           </a:fontRef>
         </p:style>
         <p:txBody>
-          <a:bodyPr rtlCol="0" anchor="ctr"/>
+          <a:bodyPr rtlCol="0" anchor="ctr" lIns="18288" rIns="18288" tIns="18288" bIns="18288"/>
           <a:lstStyle/>
           <a:p>
             <a:pPr algn="ctr">
+              <a:spcBef>
+                <a:spcPts val="0"/>
+              </a:spcBef>
+              <a:spcAft>
+                <a:spcPts val="0"/>
+              </a:spcAft>
               <a:defRPr sz="900" b="1">
                 <a:solidFill>
                   <a:srgbClr val="535766"/>
@@ -13820,10 +15261,16 @@
           </a:fontRef>
         </p:style>
         <p:txBody>
-          <a:bodyPr rtlCol="0" anchor="ctr"/>
+          <a:bodyPr rtlCol="0" anchor="ctr" lIns="18288" rIns="18288" tIns="18288" bIns="18288"/>
           <a:lstStyle/>
           <a:p>
             <a:pPr algn="ctr">
+              <a:spcBef>
+                <a:spcPts val="0"/>
+              </a:spcBef>
+              <a:spcAft>
+                <a:spcPts val="0"/>
+              </a:spcAft>
               <a:defRPr sz="900" b="1">
                 <a:solidFill>
                   <a:srgbClr val="FFFFFF"/>
@@ -13874,10 +15321,16 @@
           </a:fontRef>
         </p:style>
         <p:txBody>
-          <a:bodyPr rtlCol="0" anchor="ctr"/>
+          <a:bodyPr rtlCol="0" anchor="ctr" lIns="18288" rIns="18288" tIns="18288" bIns="18288"/>
           <a:lstStyle/>
           <a:p>
             <a:pPr algn="ctr">
+              <a:spcBef>
+                <a:spcPts val="0"/>
+              </a:spcBef>
+              <a:spcAft>
+                <a:spcPts val="0"/>
+              </a:spcAft>
               <a:defRPr sz="900" b="1">
                 <a:solidFill>
                   <a:srgbClr val="535766"/>
@@ -13928,10 +15381,16 @@
           </a:fontRef>
         </p:style>
         <p:txBody>
-          <a:bodyPr rtlCol="0" anchor="ctr"/>
+          <a:bodyPr rtlCol="0" anchor="ctr" lIns="18288" rIns="18288" tIns="18288" bIns="18288"/>
           <a:lstStyle/>
           <a:p>
             <a:pPr algn="ctr">
+              <a:spcBef>
+                <a:spcPts val="0"/>
+              </a:spcBef>
+              <a:spcAft>
+                <a:spcPts val="0"/>
+              </a:spcAft>
               <a:defRPr sz="900" b="1">
                 <a:solidFill>
                   <a:srgbClr val="535766"/>
@@ -13998,10 +15457,16 @@
           </a:fontRef>
         </p:style>
         <p:txBody>
-          <a:bodyPr rtlCol="0" anchor="ctr" wrap="square"/>
+          <a:bodyPr rtlCol="0" anchor="ctr" wrap="square" tIns="18288" bIns="18288"/>
           <a:lstStyle/>
           <a:p>
             <a:pPr algn="ctr">
+              <a:spcBef>
+                <a:spcPts val="0"/>
+              </a:spcBef>
+              <a:spcAft>
+                <a:spcPts val="0"/>
+              </a:spcAft>
               <a:defRPr sz="1000" b="1">
                 <a:solidFill>
                   <a:srgbClr val="FFFFFF"/>
@@ -14031,13 +15496,16 @@
           <a:noFill/>
         </p:spPr>
         <p:txBody>
-          <a:bodyPr wrap="square">
+          <a:bodyPr wrap="square" lIns="0" rIns="0" tIns="0" bIns="0">
             <a:spAutoFit/>
           </a:bodyPr>
           <a:lstStyle/>
           <a:p>
             <a:pPr>
-              <a:defRPr sz="1450" b="1">
+              <a:spcAft>
+                <a:spcPts val="300"/>
+              </a:spcAft>
+              <a:defRPr sz="1400" b="1">
                 <a:solidFill>
                   <a:srgbClr val="282C3F"/>
                 </a:solidFill>
@@ -14049,7 +15517,13 @@
           </a:p>
           <a:p>
             <a:pPr>
-              <a:defRPr sz="1150" b="1">
+              <a:spcBef>
+                <a:spcPts val="200"/>
+              </a:spcBef>
+              <a:spcAft>
+                <a:spcPts val="400"/>
+              </a:spcAft>
+              <a:defRPr sz="1050" b="1">
                 <a:solidFill>
                   <a:srgbClr val="FF3F6C"/>
                 </a:solidFill>
@@ -14078,7 +15552,7 @@
           <a:noFill/>
         </p:spPr>
         <p:txBody>
-          <a:bodyPr wrap="none">
+          <a:bodyPr wrap="none" lIns="0" rIns="0" tIns="0" bIns="0">
             <a:spAutoFit/>
           </a:bodyPr>
           <a:lstStyle/>
@@ -14149,8 +15623,8 @@
         </p:nvSpPr>
         <p:spPr>
           <a:xfrm>
-            <a:off x="777240" y="1783080"/>
-            <a:ext cx="3840480" cy="3520440"/>
+            <a:off x="749808" y="1755648"/>
+            <a:ext cx="3895344" cy="3575304"/>
           </a:xfrm>
           <a:prstGeom prst="rect">
             <a:avLst/>
@@ -14158,12 +15632,15 @@
           <a:noFill/>
         </p:spPr>
         <p:txBody>
-          <a:bodyPr wrap="square">
+          <a:bodyPr wrap="square" tIns="73152" bIns="73152">
             <a:spAutoFit/>
           </a:bodyPr>
           <a:lstStyle/>
           <a:p>
             <a:pPr>
+              <a:spcAft>
+                <a:spcPts val="800"/>
+              </a:spcAft>
               <a:defRPr sz="1100" b="1">
                 <a:solidFill>
                   <a:srgbClr val="FF3F6C"/>
@@ -14176,7 +15653,16 @@
           </a:p>
           <a:p>
             <a:pPr>
-              <a:defRPr sz="1000"/>
+              <a:lnSpc>
+                <a:spcPct val="118000"/>
+              </a:lnSpc>
+              <a:spcBef>
+                <a:spcPts val="200"/>
+              </a:spcBef>
+              <a:spcAft>
+                <a:spcPts val="500"/>
+              </a:spcAft>
+              <a:defRPr sz="950"/>
             </a:pPr>
             <a:r>
               <a:rPr b="1">
@@ -14205,7 +15691,16 @@
           </a:p>
           <a:p>
             <a:pPr>
-              <a:defRPr sz="1000"/>
+              <a:lnSpc>
+                <a:spcPct val="118000"/>
+              </a:lnSpc>
+              <a:spcBef>
+                <a:spcPts val="200"/>
+              </a:spcBef>
+              <a:spcAft>
+                <a:spcPts val="500"/>
+              </a:spcAft>
+              <a:defRPr sz="950"/>
             </a:pPr>
             <a:r>
               <a:rPr b="1">
@@ -14234,7 +15729,16 @@
           </a:p>
           <a:p>
             <a:pPr>
-              <a:defRPr sz="1000"/>
+              <a:lnSpc>
+                <a:spcPct val="118000"/>
+              </a:lnSpc>
+              <a:spcBef>
+                <a:spcPts val="200"/>
+              </a:spcBef>
+              <a:spcAft>
+                <a:spcPts val="500"/>
+              </a:spcAft>
+              <a:defRPr sz="950"/>
             </a:pPr>
             <a:r>
               <a:rPr b="1">
@@ -14263,7 +15767,16 @@
           </a:p>
           <a:p>
             <a:pPr>
-              <a:defRPr sz="1000"/>
+              <a:lnSpc>
+                <a:spcPct val="118000"/>
+              </a:lnSpc>
+              <a:spcBef>
+                <a:spcPts val="200"/>
+              </a:spcBef>
+              <a:spcAft>
+                <a:spcPts val="500"/>
+              </a:spcAft>
+              <a:defRPr sz="950"/>
             </a:pPr>
             <a:r>
               <a:rPr b="1">
@@ -14345,8 +15858,8 @@
         </p:nvSpPr>
         <p:spPr>
           <a:xfrm>
-            <a:off x="5029200" y="1783080"/>
-            <a:ext cx="3840480" cy="3520440"/>
+            <a:off x="5001768" y="1755648"/>
+            <a:ext cx="3895344" cy="3575304"/>
           </a:xfrm>
           <a:prstGeom prst="rect">
             <a:avLst/>
@@ -14354,12 +15867,15 @@
           <a:noFill/>
         </p:spPr>
         <p:txBody>
-          <a:bodyPr wrap="square">
+          <a:bodyPr wrap="square" tIns="73152" bIns="73152">
             <a:spAutoFit/>
           </a:bodyPr>
           <a:lstStyle/>
           <a:p>
             <a:pPr>
+              <a:spcAft>
+                <a:spcPts val="800"/>
+              </a:spcAft>
               <a:defRPr sz="1100" b="1">
                 <a:solidFill>
                   <a:srgbClr val="FF3F6C"/>
@@ -14372,7 +15888,16 @@
           </a:p>
           <a:p>
             <a:pPr>
-              <a:defRPr sz="1000"/>
+              <a:lnSpc>
+                <a:spcPct val="118000"/>
+              </a:lnSpc>
+              <a:spcBef>
+                <a:spcPts val="200"/>
+              </a:spcBef>
+              <a:spcAft>
+                <a:spcPts val="500"/>
+              </a:spcAft>
+              <a:defRPr sz="950"/>
             </a:pPr>
             <a:r>
               <a:rPr b="1">
@@ -14401,7 +15926,16 @@
           </a:p>
           <a:p>
             <a:pPr>
-              <a:defRPr sz="1000"/>
+              <a:lnSpc>
+                <a:spcPct val="118000"/>
+              </a:lnSpc>
+              <a:spcBef>
+                <a:spcPts val="200"/>
+              </a:spcBef>
+              <a:spcAft>
+                <a:spcPts val="500"/>
+              </a:spcAft>
+              <a:defRPr sz="950"/>
             </a:pPr>
             <a:r>
               <a:rPr b="1">
@@ -14430,7 +15964,16 @@
           </a:p>
           <a:p>
             <a:pPr>
-              <a:defRPr sz="1000"/>
+              <a:lnSpc>
+                <a:spcPct val="118000"/>
+              </a:lnSpc>
+              <a:spcBef>
+                <a:spcPts val="200"/>
+              </a:spcBef>
+              <a:spcAft>
+                <a:spcPts val="500"/>
+              </a:spcAft>
+              <a:defRPr sz="950"/>
             </a:pPr>
             <a:r>
               <a:rPr b="1">
@@ -14459,7 +16002,16 @@
           </a:p>
           <a:p>
             <a:pPr>
-              <a:defRPr sz="1000"/>
+              <a:lnSpc>
+                <a:spcPct val="118000"/>
+              </a:lnSpc>
+              <a:spcBef>
+                <a:spcPts val="200"/>
+              </a:spcBef>
+              <a:spcAft>
+                <a:spcPts val="500"/>
+              </a:spcAft>
+              <a:defRPr sz="950"/>
             </a:pPr>
             <a:r>
               <a:rPr b="1">
@@ -14610,8 +16162,8 @@
         </p:nvSpPr>
         <p:spPr>
           <a:xfrm>
-            <a:off x="777240" y="5605272"/>
-            <a:ext cx="10637215" cy="493776"/>
+            <a:off x="777240" y="5586984"/>
+            <a:ext cx="10637215" cy="530352"/>
           </a:xfrm>
           <a:prstGeom prst="rect">
             <a:avLst/>
@@ -14619,13 +16171,16 @@
           <a:noFill/>
         </p:spPr>
         <p:txBody>
-          <a:bodyPr wrap="square">
+          <a:bodyPr wrap="square" tIns="36576" bIns="36576">
             <a:spAutoFit/>
           </a:bodyPr>
           <a:lstStyle/>
           <a:p>
             <a:pPr>
-              <a:defRPr sz="1000" b="1">
+              <a:spcAft>
+                <a:spcPts val="200"/>
+              </a:spcAft>
+              <a:defRPr sz="950" b="1">
                 <a:solidFill>
                   <a:srgbClr val="4338CA"/>
                 </a:solidFill>
@@ -14637,7 +16192,13 @@
           </a:p>
           <a:p>
             <a:pPr>
-              <a:defRPr sz="1000" b="1">
+              <a:lnSpc>
+                <a:spcPct val="115000"/>
+              </a:lnSpc>
+              <a:spcBef>
+                <a:spcPts val="0"/>
+              </a:spcBef>
+              <a:defRPr sz="950" b="1">
                 <a:solidFill>
                   <a:srgbClr val="282C3F"/>
                 </a:solidFill>
@@ -14687,10 +16248,16 @@
           </a:fontRef>
         </p:style>
         <p:txBody>
-          <a:bodyPr rtlCol="0" anchor="ctr"/>
+          <a:bodyPr rtlCol="0" anchor="ctr" lIns="18288" rIns="18288" tIns="18288" bIns="18288"/>
           <a:lstStyle/>
           <a:p>
             <a:pPr algn="ctr">
+              <a:spcBef>
+                <a:spcPts val="0"/>
+              </a:spcBef>
+              <a:spcAft>
+                <a:spcPts val="0"/>
+              </a:spcAft>
               <a:defRPr sz="900" b="1">
                 <a:solidFill>
                   <a:srgbClr val="535766"/>
@@ -14741,10 +16308,16 @@
           </a:fontRef>
         </p:style>
         <p:txBody>
-          <a:bodyPr rtlCol="0" anchor="ctr"/>
+          <a:bodyPr rtlCol="0" anchor="ctr" lIns="18288" rIns="18288" tIns="18288" bIns="18288"/>
           <a:lstStyle/>
           <a:p>
             <a:pPr algn="ctr">
+              <a:spcBef>
+                <a:spcPts val="0"/>
+              </a:spcBef>
+              <a:spcAft>
+                <a:spcPts val="0"/>
+              </a:spcAft>
               <a:defRPr sz="900" b="1">
                 <a:solidFill>
                   <a:srgbClr val="535766"/>
@@ -14795,10 +16368,16 @@
           </a:fontRef>
         </p:style>
         <p:txBody>
-          <a:bodyPr rtlCol="0" anchor="ctr"/>
+          <a:bodyPr rtlCol="0" anchor="ctr" lIns="18288" rIns="18288" tIns="18288" bIns="18288"/>
           <a:lstStyle/>
           <a:p>
             <a:pPr algn="ctr">
+              <a:spcBef>
+                <a:spcPts val="0"/>
+              </a:spcBef>
+              <a:spcAft>
+                <a:spcPts val="0"/>
+              </a:spcAft>
               <a:defRPr sz="900" b="1">
                 <a:solidFill>
                   <a:srgbClr val="535766"/>
@@ -14849,10 +16428,16 @@
           </a:fontRef>
         </p:style>
         <p:txBody>
-          <a:bodyPr rtlCol="0" anchor="ctr"/>
+          <a:bodyPr rtlCol="0" anchor="ctr" lIns="18288" rIns="18288" tIns="18288" bIns="18288"/>
           <a:lstStyle/>
           <a:p>
             <a:pPr algn="ctr">
+              <a:spcBef>
+                <a:spcPts val="0"/>
+              </a:spcBef>
+              <a:spcAft>
+                <a:spcPts val="0"/>
+              </a:spcAft>
               <a:defRPr sz="900" b="1">
                 <a:solidFill>
                   <a:srgbClr val="535766"/>
@@ -14903,10 +16488,16 @@
           </a:fontRef>
         </p:style>
         <p:txBody>
-          <a:bodyPr rtlCol="0" anchor="ctr"/>
+          <a:bodyPr rtlCol="0" anchor="ctr" lIns="18288" rIns="18288" tIns="18288" bIns="18288"/>
           <a:lstStyle/>
           <a:p>
             <a:pPr algn="ctr">
+              <a:spcBef>
+                <a:spcPts val="0"/>
+              </a:spcBef>
+              <a:spcAft>
+                <a:spcPts val="0"/>
+              </a:spcAft>
               <a:defRPr sz="900" b="1">
                 <a:solidFill>
                   <a:srgbClr val="535766"/>
@@ -14957,10 +16548,16 @@
           </a:fontRef>
         </p:style>
         <p:txBody>
-          <a:bodyPr rtlCol="0" anchor="ctr"/>
+          <a:bodyPr rtlCol="0" anchor="ctr" lIns="18288" rIns="18288" tIns="18288" bIns="18288"/>
           <a:lstStyle/>
           <a:p>
             <a:pPr algn="ctr">
+              <a:spcBef>
+                <a:spcPts val="0"/>
+              </a:spcBef>
+              <a:spcAft>
+                <a:spcPts val="0"/>
+              </a:spcAft>
               <a:defRPr sz="900" b="1">
                 <a:solidFill>
                   <a:srgbClr val="535766"/>
@@ -15011,10 +16608,16 @@
           </a:fontRef>
         </p:style>
         <p:txBody>
-          <a:bodyPr rtlCol="0" anchor="ctr"/>
+          <a:bodyPr rtlCol="0" anchor="ctr" lIns="18288" rIns="18288" tIns="18288" bIns="18288"/>
           <a:lstStyle/>
           <a:p>
             <a:pPr algn="ctr">
+              <a:spcBef>
+                <a:spcPts val="0"/>
+              </a:spcBef>
+              <a:spcAft>
+                <a:spcPts val="0"/>
+              </a:spcAft>
               <a:defRPr sz="900" b="1">
                 <a:solidFill>
                   <a:srgbClr val="535766"/>
@@ -15065,10 +16668,16 @@
           </a:fontRef>
         </p:style>
         <p:txBody>
-          <a:bodyPr rtlCol="0" anchor="ctr"/>
+          <a:bodyPr rtlCol="0" anchor="ctr" lIns="18288" rIns="18288" tIns="18288" bIns="18288"/>
           <a:lstStyle/>
           <a:p>
             <a:pPr algn="ctr">
+              <a:spcBef>
+                <a:spcPts val="0"/>
+              </a:spcBef>
+              <a:spcAft>
+                <a:spcPts val="0"/>
+              </a:spcAft>
               <a:defRPr sz="900" b="1">
                 <a:solidFill>
                   <a:srgbClr val="535766"/>
@@ -15119,10 +16728,16 @@
           </a:fontRef>
         </p:style>
         <p:txBody>
-          <a:bodyPr rtlCol="0" anchor="ctr"/>
+          <a:bodyPr rtlCol="0" anchor="ctr" lIns="18288" rIns="18288" tIns="18288" bIns="18288"/>
           <a:lstStyle/>
           <a:p>
             <a:pPr algn="ctr">
+              <a:spcBef>
+                <a:spcPts val="0"/>
+              </a:spcBef>
+              <a:spcAft>
+                <a:spcPts val="0"/>
+              </a:spcAft>
               <a:defRPr sz="900" b="1">
                 <a:solidFill>
                   <a:srgbClr val="FFFFFF"/>
@@ -15173,10 +16788,16 @@
           </a:fontRef>
         </p:style>
         <p:txBody>
-          <a:bodyPr rtlCol="0" anchor="ctr"/>
+          <a:bodyPr rtlCol="0" anchor="ctr" lIns="18288" rIns="18288" tIns="18288" bIns="18288"/>
           <a:lstStyle/>
           <a:p>
             <a:pPr algn="ctr">
+              <a:spcBef>
+                <a:spcPts val="0"/>
+              </a:spcBef>
+              <a:spcAft>
+                <a:spcPts val="0"/>
+              </a:spcAft>
               <a:defRPr sz="900" b="1">
                 <a:solidFill>
                   <a:srgbClr val="535766"/>

</xml_diff>